<commit_message>
style(slides): update hvac presentation slides to 18pt baseline with bold styling
</commit_message>
<xml_diff>
--- a/public/slides/hvac-precooling-slides.pptx
+++ b/public/slides/hvac-precooling-slides.pptx
@@ -3107,7 +3107,7 @@
         <p:spPr>
           <a:xfrm>
             <a:off x="0" y="0"/>
-            <a:ext cx="1901952" cy="6858000"/>
+            <a:ext cx="2011680" cy="6858000"/>
           </a:xfrm>
           <a:prstGeom prst="rect">
             <a:avLst/>
@@ -3149,8 +3149,8 @@
         </p:nvSpPr>
         <p:spPr>
           <a:xfrm>
-            <a:off x="320040" y="1645920"/>
-            <a:ext cx="1371600" cy="1097280"/>
+            <a:off x="365760" y="1645920"/>
+            <a:ext cx="1463040" cy="1371600"/>
           </a:xfrm>
           <a:prstGeom prst="rect">
             <a:avLst/>
@@ -3164,7 +3164,7 @@
           <a:lstStyle/>
           <a:p>
             <a:pPr>
-              <a:defRPr sz="1400" b="1">
+              <a:defRPr sz="1600" b="1">
                 <a:solidFill>
                   <a:srgbClr val="FFFFFF"/>
                 </a:solidFill>
@@ -3193,8 +3193,8 @@
         </p:nvSpPr>
         <p:spPr>
           <a:xfrm>
-            <a:off x="320040" y="6035040"/>
-            <a:ext cx="1371600" cy="457200"/>
+            <a:off x="365760" y="5943600"/>
+            <a:ext cx="1463040" cy="548640"/>
           </a:xfrm>
           <a:prstGeom prst="rect">
             <a:avLst/>
@@ -3208,7 +3208,7 @@
           <a:lstStyle/>
           <a:p>
             <a:pPr>
-              <a:defRPr sz="1800" b="1">
+              <a:defRPr sz="2200" b="1">
                 <a:solidFill>
                   <a:srgbClr val="FFFFFF"/>
                 </a:solidFill>
@@ -3229,8 +3229,8 @@
         </p:nvSpPr>
         <p:spPr>
           <a:xfrm>
-            <a:off x="2560320" y="2011680"/>
-            <a:ext cx="8686800" cy="1645920"/>
+            <a:off x="2651760" y="1920240"/>
+            <a:ext cx="8686800" cy="1828800"/>
           </a:xfrm>
           <a:prstGeom prst="rect">
             <a:avLst/>
@@ -3244,7 +3244,7 @@
           <a:lstStyle/>
           <a:p>
             <a:pPr>
-              <a:defRPr sz="2500" b="1">
+              <a:defRPr sz="2800" b="1">
                 <a:solidFill>
                   <a:srgbClr val="111111"/>
                 </a:solidFill>
@@ -3258,9 +3258,9 @@
           <a:p>
             <a:pPr>
               <a:spcBef>
-                <a:spcPts val="2000"/>
+                <a:spcPts val="2200"/>
               </a:spcBef>
-              <a:defRPr sz="2200" b="1">
+              <a:defRPr sz="2400" b="1">
                 <a:solidFill>
                   <a:srgbClr val="111111"/>
                 </a:solidFill>
@@ -3281,8 +3281,8 @@
         </p:nvSpPr>
         <p:spPr>
           <a:xfrm>
-            <a:off x="5486400" y="3474720"/>
-            <a:ext cx="4572000" cy="2560320"/>
+            <a:off x="5486400" y="3383280"/>
+            <a:ext cx="4754880" cy="2743200"/>
           </a:xfrm>
           <a:prstGeom prst="rect">
             <a:avLst/>
@@ -3299,9 +3299,9 @@
               <a:spcBef>
                 <a:spcPts val="0"/>
               </a:spcBef>
-              <a:defRPr sz="1200" b="0">
-                <a:solidFill>
-                  <a:srgbClr val="333333"/>
+              <a:defRPr sz="1500" b="1">
+                <a:solidFill>
+                  <a:srgbClr val="222222"/>
                 </a:solidFill>
                 <a:latin typeface="BIZ UDPGothic"/>
               </a:defRPr>
@@ -3315,9 +3315,9 @@
               <a:spcBef>
                 <a:spcPts val="200"/>
               </a:spcBef>
-              <a:defRPr sz="1200" b="0">
-                <a:solidFill>
-                  <a:srgbClr val="333333"/>
+              <a:defRPr sz="1500" b="1">
+                <a:solidFill>
+                  <a:srgbClr val="222222"/>
                 </a:solidFill>
                 <a:latin typeface="BIZ UDPGothic"/>
               </a:defRPr>
@@ -3329,11 +3329,11 @@
           <a:p>
             <a:pPr algn="r">
               <a:spcBef>
-                <a:spcPts val="1600"/>
+                <a:spcPts val="1800"/>
               </a:spcBef>
-              <a:defRPr sz="1300" b="0">
-                <a:solidFill>
-                  <a:srgbClr val="333333"/>
+              <a:defRPr sz="1500" b="0">
+                <a:solidFill>
+                  <a:srgbClr val="222222"/>
                 </a:solidFill>
                 <a:latin typeface="BIZ UDPGothic"/>
               </a:defRPr>
@@ -3347,9 +3347,9 @@
               <a:spcBef>
                 <a:spcPts val="600"/>
               </a:spcBef>
-              <a:defRPr sz="1300" b="0">
-                <a:solidFill>
-                  <a:srgbClr val="333333"/>
+              <a:defRPr sz="1500" b="0">
+                <a:solidFill>
+                  <a:srgbClr val="222222"/>
                 </a:solidFill>
                 <a:latin typeface="BIZ UDPGothic"/>
               </a:defRPr>
@@ -3363,9 +3363,9 @@
               <a:spcBef>
                 <a:spcPts val="200"/>
               </a:spcBef>
-              <a:defRPr sz="1300" b="0">
-                <a:solidFill>
-                  <a:srgbClr val="333333"/>
+              <a:defRPr sz="1500" b="0">
+                <a:solidFill>
+                  <a:srgbClr val="222222"/>
                 </a:solidFill>
                 <a:latin typeface="BIZ UDPGothic"/>
               </a:defRPr>
@@ -3377,11 +3377,11 @@
           <a:p>
             <a:pPr algn="r">
               <a:spcBef>
-                <a:spcPts val="600"/>
+                <a:spcPts val="800"/>
               </a:spcBef>
-              <a:defRPr sz="1600" b="1">
-                <a:solidFill>
-                  <a:srgbClr val="333333"/>
+              <a:defRPr sz="2000" b="1">
+                <a:solidFill>
+                  <a:srgbClr val="222222"/>
                 </a:solidFill>
                 <a:latin typeface="BIZ UDPGothic"/>
               </a:defRPr>
@@ -3419,7 +3419,7 @@
         <p:spPr>
           <a:xfrm>
             <a:off x="0" y="0"/>
-            <a:ext cx="12191695" cy="530352"/>
+            <a:ext cx="12191695" cy="585216"/>
           </a:xfrm>
           <a:prstGeom prst="rect">
             <a:avLst/>
@@ -3462,7 +3462,7 @@
         <p:spPr>
           <a:xfrm>
             <a:off x="301752" y="73152"/>
-            <a:ext cx="9144000" cy="411480"/>
+            <a:ext cx="9144000" cy="457200"/>
           </a:xfrm>
           <a:prstGeom prst="rect">
             <a:avLst/>
@@ -3476,7 +3476,7 @@
           <a:lstStyle/>
           <a:p>
             <a:pPr>
-              <a:defRPr sz="1800" b="1">
+              <a:defRPr sz="2000" b="1">
                 <a:solidFill>
                   <a:srgbClr val="FFFFFF"/>
                 </a:solidFill>
@@ -3497,8 +3497,8 @@
         </p:nvSpPr>
         <p:spPr>
           <a:xfrm>
-            <a:off x="10789920" y="128016"/>
-            <a:ext cx="484632" cy="274320"/>
+            <a:off x="10698480" y="137160"/>
+            <a:ext cx="530352" cy="301752"/>
           </a:xfrm>
           <a:prstGeom prst="roundRect">
             <a:avLst/>
@@ -3531,7 +3531,7 @@
           <a:lstStyle/>
           <a:p>
             <a:pPr algn="ctr">
-              <a:defRPr sz="1100" i="1">
+              <a:defRPr sz="1200" i="1" b="1">
                 <a:solidFill>
                   <a:srgbClr val="E8F1F8"/>
                 </a:solidFill>
@@ -3553,7 +3553,7 @@
         <p:spPr>
           <a:xfrm>
             <a:off x="11430000" y="73152"/>
-            <a:ext cx="548640" cy="411480"/>
+            <a:ext cx="548640" cy="457200"/>
           </a:xfrm>
           <a:prstGeom prst="rect">
             <a:avLst/>
@@ -3567,7 +3567,7 @@
           <a:lstStyle/>
           <a:p>
             <a:pPr algn="ctr">
-              <a:defRPr sz="1800" b="1">
+              <a:defRPr sz="2000" b="1">
                 <a:solidFill>
                   <a:srgbClr val="FFFFFF"/>
                 </a:solidFill>
@@ -3603,7 +3603,7 @@
           <a:lstStyle/>
           <a:p>
             <a:pPr algn="r">
-              <a:defRPr sz="800">
+              <a:defRPr sz="900">
                 <a:solidFill>
                   <a:srgbClr val="666666"/>
                 </a:solidFill>
@@ -3624,8 +3624,8 @@
         </p:nvSpPr>
         <p:spPr>
           <a:xfrm>
-            <a:off x="822960" y="914400"/>
-            <a:ext cx="10515600" cy="5029200"/>
+            <a:off x="731520" y="914400"/>
+            <a:ext cx="10698480" cy="5120640"/>
           </a:xfrm>
           <a:prstGeom prst="rect">
             <a:avLst/>
@@ -3642,7 +3642,7 @@
               <a:spcBef>
                 <a:spcPts val="0"/>
               </a:spcBef>
-              <a:defRPr sz="1400" b="1">
+              <a:defRPr sz="2000" b="1">
                 <a:solidFill>
                   <a:srgbClr val="111111"/>
                 </a:solidFill>
@@ -3656,9 +3656,9 @@
           <a:p>
             <a:pPr>
               <a:spcBef>
-                <a:spcPts val="600"/>
+                <a:spcPts val="800"/>
               </a:spcBef>
-              <a:defRPr sz="1300" b="1">
+              <a:defRPr sz="1800" b="1">
                 <a:solidFill>
                   <a:srgbClr val="111111"/>
                 </a:solidFill>
@@ -3672,11 +3672,11 @@
           <a:p>
             <a:pPr>
               <a:spcBef>
-                <a:spcPts val="200"/>
+                <a:spcPts val="400"/>
               </a:spcBef>
-              <a:defRPr sz="1250" b="0">
-                <a:solidFill>
-                  <a:srgbClr val="333333"/>
+              <a:defRPr sz="1700" b="0">
+                <a:solidFill>
+                  <a:srgbClr val="222222"/>
                 </a:solidFill>
                 <a:latin typeface="BIZ UDPGothic"/>
               </a:defRPr>
@@ -3688,9 +3688,9 @@
           <a:p>
             <a:pPr>
               <a:spcBef>
-                <a:spcPts val="1000"/>
+                <a:spcPts val="1400"/>
               </a:spcBef>
-              <a:defRPr sz="1300" b="1">
+              <a:defRPr sz="1800" b="1">
                 <a:solidFill>
                   <a:srgbClr val="111111"/>
                 </a:solidFill>
@@ -3704,11 +3704,11 @@
           <a:p>
             <a:pPr>
               <a:spcBef>
-                <a:spcPts val="200"/>
+                <a:spcPts val="400"/>
               </a:spcBef>
-              <a:defRPr sz="1250" b="0">
-                <a:solidFill>
-                  <a:srgbClr val="333333"/>
+              <a:defRPr sz="1700" b="0">
+                <a:solidFill>
+                  <a:srgbClr val="222222"/>
                 </a:solidFill>
                 <a:latin typeface="BIZ UDPGothic"/>
               </a:defRPr>
@@ -3720,9 +3720,9 @@
           <a:p>
             <a:pPr>
               <a:spcBef>
-                <a:spcPts val="2000"/>
+                <a:spcPts val="2600"/>
               </a:spcBef>
-              <a:defRPr sz="1400" b="1">
+              <a:defRPr sz="2000" b="1">
                 <a:solidFill>
                   <a:srgbClr val="111111"/>
                 </a:solidFill>
@@ -3736,9 +3736,9 @@
           <a:p>
             <a:pPr>
               <a:spcBef>
-                <a:spcPts val="600"/>
+                <a:spcPts val="800"/>
               </a:spcBef>
-              <a:defRPr sz="1300" b="1">
+              <a:defRPr sz="1800" b="1">
                 <a:solidFill>
                   <a:srgbClr val="111111"/>
                 </a:solidFill>
@@ -3752,9 +3752,9 @@
           <a:p>
             <a:pPr>
               <a:spcBef>
-                <a:spcPts val="600"/>
+                <a:spcPts val="800"/>
               </a:spcBef>
-              <a:defRPr sz="1300" b="1">
+              <a:defRPr sz="1800" b="1">
                 <a:solidFill>
                   <a:srgbClr val="111111"/>
                 </a:solidFill>
@@ -3768,9 +3768,9 @@
           <a:p>
             <a:pPr>
               <a:spcBef>
-                <a:spcPts val="600"/>
+                <a:spcPts val="800"/>
               </a:spcBef>
-              <a:defRPr sz="1300" b="1">
+              <a:defRPr sz="1800" b="1">
                 <a:solidFill>
                   <a:srgbClr val="111111"/>
                 </a:solidFill>
@@ -3784,9 +3784,9 @@
           <a:p>
             <a:pPr>
               <a:spcBef>
-                <a:spcPts val="600"/>
+                <a:spcPts val="800"/>
               </a:spcBef>
-              <a:defRPr sz="1300" b="1">
+              <a:defRPr sz="1800" b="1">
                 <a:solidFill>
                   <a:srgbClr val="111111"/>
                 </a:solidFill>
@@ -3794,7 +3794,7 @@
               </a:defRPr>
             </a:pPr>
             <a:r>
-              <a:t>4. データ読み取り→モデル再学習</a:t>
+              <a:t>4. データ読み取り → モデル再学習</a:t>
             </a:r>
           </a:p>
         </p:txBody>
@@ -3826,7 +3826,7 @@
         <p:spPr>
           <a:xfrm>
             <a:off x="0" y="0"/>
-            <a:ext cx="12191695" cy="530352"/>
+            <a:ext cx="12191695" cy="585216"/>
           </a:xfrm>
           <a:prstGeom prst="rect">
             <a:avLst/>
@@ -3869,7 +3869,7 @@
         <p:spPr>
           <a:xfrm>
             <a:off x="301752" y="73152"/>
-            <a:ext cx="9144000" cy="411480"/>
+            <a:ext cx="9144000" cy="457200"/>
           </a:xfrm>
           <a:prstGeom prst="rect">
             <a:avLst/>
@@ -3883,7 +3883,7 @@
           <a:lstStyle/>
           <a:p>
             <a:pPr>
-              <a:defRPr sz="1800" b="1">
+              <a:defRPr sz="2000" b="1">
                 <a:solidFill>
                   <a:srgbClr val="FFFFFF"/>
                 </a:solidFill>
@@ -3904,8 +3904,8 @@
         </p:nvSpPr>
         <p:spPr>
           <a:xfrm>
-            <a:off x="10789920" y="128016"/>
-            <a:ext cx="484632" cy="274320"/>
+            <a:off x="10698480" y="137160"/>
+            <a:ext cx="530352" cy="301752"/>
           </a:xfrm>
           <a:prstGeom prst="roundRect">
             <a:avLst/>
@@ -3938,7 +3938,7 @@
           <a:lstStyle/>
           <a:p>
             <a:pPr algn="ctr">
-              <a:defRPr sz="1100" i="1">
+              <a:defRPr sz="1200" i="1" b="1">
                 <a:solidFill>
                   <a:srgbClr val="E8F1F8"/>
                 </a:solidFill>
@@ -3960,7 +3960,7 @@
         <p:spPr>
           <a:xfrm>
             <a:off x="11430000" y="73152"/>
-            <a:ext cx="548640" cy="411480"/>
+            <a:ext cx="548640" cy="457200"/>
           </a:xfrm>
           <a:prstGeom prst="rect">
             <a:avLst/>
@@ -3974,7 +3974,7 @@
           <a:lstStyle/>
           <a:p>
             <a:pPr algn="ctr">
-              <a:defRPr sz="1800" b="1">
+              <a:defRPr sz="2000" b="1">
                 <a:solidFill>
                   <a:srgbClr val="FFFFFF"/>
                 </a:solidFill>
@@ -4010,7 +4010,7 @@
           <a:lstStyle/>
           <a:p>
             <a:pPr algn="r">
-              <a:defRPr sz="800">
+              <a:defRPr sz="900">
                 <a:solidFill>
                   <a:srgbClr val="666666"/>
                 </a:solidFill>
@@ -4031,8 +4031,8 @@
         </p:nvSpPr>
         <p:spPr>
           <a:xfrm>
-            <a:off x="822960" y="1097280"/>
-            <a:ext cx="10515600" cy="4572000"/>
+            <a:off x="731520" y="1097280"/>
+            <a:ext cx="10698480" cy="4754880"/>
           </a:xfrm>
           <a:prstGeom prst="rect">
             <a:avLst/>
@@ -4049,7 +4049,7 @@
               <a:spcBef>
                 <a:spcPts val="0"/>
               </a:spcBef>
-              <a:defRPr sz="1400" b="1">
+              <a:defRPr sz="2000" b="1">
                 <a:solidFill>
                   <a:srgbClr val="111111"/>
                 </a:solidFill>
@@ -4063,25 +4063,29 @@
           <a:p>
             <a:pPr>
               <a:spcBef>
-                <a:spcPts val="600"/>
+                <a:spcPts val="800"/>
               </a:spcBef>
-              <a:defRPr sz="1300" b="0">
-                <a:solidFill>
-                  <a:srgbClr val="333333"/>
-                </a:solidFill>
-                <a:latin typeface="BIZ UDPGothic"/>
-              </a:defRPr>
-            </a:pPr>
-            <a:r>
-              <a:t>・お客様目線でのアプリケーション開発は相手の要望を想像しながらしなければいけない部分もあり、難しかった。</a:t>
+              <a:defRPr sz="1750" b="0">
+                <a:solidFill>
+                  <a:srgbClr val="222222"/>
+                </a:solidFill>
+                <a:latin typeface="BIZ UDPGothic"/>
+              </a:defRPr>
+            </a:pPr>
+            <a:r>
+              <a:t>・お客様目線でのアプリケーション開発は相手の要望を想像しながらしなければいけない部分もあり、</a:t>
+            </a:r>
+            <a:br/>
+            <a:r>
+              <a:t>  難しかった。</a:t>
             </a:r>
           </a:p>
           <a:p>
             <a:pPr>
               <a:spcBef>
-                <a:spcPts val="2400"/>
+                <a:spcPts val="3000"/>
               </a:spcBef>
-              <a:defRPr sz="1400" b="1">
+              <a:defRPr sz="2000" b="1">
                 <a:solidFill>
                   <a:srgbClr val="111111"/>
                 </a:solidFill>
@@ -4095,11 +4099,11 @@
           <a:p>
             <a:pPr>
               <a:spcBef>
-                <a:spcPts val="600"/>
+                <a:spcPts val="800"/>
               </a:spcBef>
-              <a:defRPr sz="1300" b="0">
-                <a:solidFill>
-                  <a:srgbClr val="333333"/>
+              <a:defRPr sz="1750" b="0">
+                <a:solidFill>
+                  <a:srgbClr val="222222"/>
                 </a:solidFill>
                 <a:latin typeface="BIZ UDPGothic"/>
               </a:defRPr>
@@ -4141,7 +4145,7 @@
         <p:spPr>
           <a:xfrm>
             <a:off x="0" y="0"/>
-            <a:ext cx="12191695" cy="530352"/>
+            <a:ext cx="12191695" cy="585216"/>
           </a:xfrm>
           <a:prstGeom prst="rect">
             <a:avLst/>
@@ -4184,7 +4188,7 @@
         <p:spPr>
           <a:xfrm>
             <a:off x="301752" y="73152"/>
-            <a:ext cx="9144000" cy="411480"/>
+            <a:ext cx="9144000" cy="457200"/>
           </a:xfrm>
           <a:prstGeom prst="rect">
             <a:avLst/>
@@ -4198,7 +4202,7 @@
           <a:lstStyle/>
           <a:p>
             <a:pPr>
-              <a:defRPr sz="1800" b="1">
+              <a:defRPr sz="2000" b="1">
                 <a:solidFill>
                   <a:srgbClr val="FFFFFF"/>
                 </a:solidFill>
@@ -4219,8 +4223,8 @@
         </p:nvSpPr>
         <p:spPr>
           <a:xfrm>
-            <a:off x="10789920" y="128016"/>
-            <a:ext cx="484632" cy="274320"/>
+            <a:off x="10698480" y="137160"/>
+            <a:ext cx="530352" cy="301752"/>
           </a:xfrm>
           <a:prstGeom prst="roundRect">
             <a:avLst/>
@@ -4253,7 +4257,7 @@
           <a:lstStyle/>
           <a:p>
             <a:pPr algn="ctr">
-              <a:defRPr sz="1100" i="1">
+              <a:defRPr sz="1200" i="1" b="1">
                 <a:solidFill>
                   <a:srgbClr val="E8F1F8"/>
                 </a:solidFill>
@@ -4275,7 +4279,7 @@
         <p:spPr>
           <a:xfrm>
             <a:off x="11430000" y="73152"/>
-            <a:ext cx="548640" cy="411480"/>
+            <a:ext cx="548640" cy="457200"/>
           </a:xfrm>
           <a:prstGeom prst="rect">
             <a:avLst/>
@@ -4289,7 +4293,7 @@
           <a:lstStyle/>
           <a:p>
             <a:pPr algn="ctr">
-              <a:defRPr sz="1800" b="1">
+              <a:defRPr sz="2000" b="1">
                 <a:solidFill>
                   <a:srgbClr val="FFFFFF"/>
                 </a:solidFill>
@@ -4325,7 +4329,7 @@
           <a:lstStyle/>
           <a:p>
             <a:pPr algn="r">
-              <a:defRPr sz="800">
+              <a:defRPr sz="900">
                 <a:solidFill>
                   <a:srgbClr val="666666"/>
                 </a:solidFill>
@@ -4354,8 +4358,8 @@
         </p:blipFill>
         <p:spPr>
           <a:xfrm>
-            <a:off x="1005840" y="1143000"/>
-            <a:ext cx="2286000" cy="2926080"/>
+            <a:off x="914400" y="1097280"/>
+            <a:ext cx="2377440" cy="3017520"/>
           </a:xfrm>
           <a:prstGeom prst="rect">
             <a:avLst/>
@@ -4378,8 +4382,8 @@
         </p:blipFill>
         <p:spPr>
           <a:xfrm>
-            <a:off x="2926080" y="3291840"/>
-            <a:ext cx="1828800" cy="1371600"/>
+            <a:off x="2926080" y="3383280"/>
+            <a:ext cx="1920240" cy="1463040"/>
           </a:xfrm>
           <a:prstGeom prst="rect">
             <a:avLst/>
@@ -4394,8 +4398,8 @@
         </p:nvSpPr>
         <p:spPr>
           <a:xfrm>
-            <a:off x="5486400" y="1280160"/>
-            <a:ext cx="6217920" cy="4754880"/>
+            <a:off x="5394960" y="1188720"/>
+            <a:ext cx="6400800" cy="5029200"/>
           </a:xfrm>
           <a:prstGeom prst="rect">
             <a:avLst/>
@@ -4412,7 +4416,7 @@
               <a:spcBef>
                 <a:spcPts val="0"/>
               </a:spcBef>
-              <a:defRPr sz="1400" b="1">
+              <a:defRPr sz="2000" b="1">
                 <a:solidFill>
                   <a:srgbClr val="111111"/>
                 </a:solidFill>
@@ -4421,6 +4425,22 @@
             </a:pPr>
             <a:r>
               <a:t>■ インターンシップに参加した理由：</a:t>
+            </a:r>
+          </a:p>
+          <a:p>
+            <a:pPr>
+              <a:spcBef>
+                <a:spcPts val="800"/>
+              </a:spcBef>
+              <a:defRPr sz="1800" b="0">
+                <a:solidFill>
+                  <a:srgbClr val="222222"/>
+                </a:solidFill>
+                <a:latin typeface="BIZ UDPGothic"/>
+              </a:defRPr>
+            </a:pPr>
+            <a:r>
+              <a:t>①大学では扱えない実データに触れる</a:t>
             </a:r>
           </a:p>
           <a:p>
@@ -4428,63 +4448,15 @@
               <a:spcBef>
                 <a:spcPts val="600"/>
               </a:spcBef>
-              <a:defRPr sz="1300" b="0">
-                <a:solidFill>
-                  <a:srgbClr val="333333"/>
-                </a:solidFill>
-                <a:latin typeface="BIZ UDPGothic"/>
-              </a:defRPr>
-            </a:pPr>
-            <a:r>
-              <a:t>①大学では扱えない実データに触れる</a:t>
-            </a:r>
-          </a:p>
-          <a:p>
-            <a:pPr>
-              <a:spcBef>
-                <a:spcPts val="400"/>
-              </a:spcBef>
-              <a:defRPr sz="1300" b="0">
-                <a:solidFill>
-                  <a:srgbClr val="333333"/>
+              <a:defRPr sz="1800" b="0">
+                <a:solidFill>
+                  <a:srgbClr val="222222"/>
                 </a:solidFill>
                 <a:latin typeface="BIZ UDPGothic"/>
               </a:defRPr>
             </a:pPr>
             <a:r>
               <a:t>②お客様目線での開発</a:t>
-            </a:r>
-          </a:p>
-          <a:p>
-            <a:pPr>
-              <a:spcBef>
-                <a:spcPts val="400"/>
-              </a:spcBef>
-              <a:defRPr sz="1300" b="0">
-                <a:solidFill>
-                  <a:srgbClr val="333333"/>
-                </a:solidFill>
-                <a:latin typeface="BIZ UDPGothic"/>
-              </a:defRPr>
-            </a:pPr>
-            <a:r>
-              <a:t>③関西の雰囲気を知る</a:t>
-            </a:r>
-          </a:p>
-          <a:p>
-            <a:pPr>
-              <a:spcBef>
-                <a:spcPts val="2200"/>
-              </a:spcBef>
-              <a:defRPr sz="1400" b="1">
-                <a:solidFill>
-                  <a:srgbClr val="111111"/>
-                </a:solidFill>
-                <a:latin typeface="BIZ UDPGothic"/>
-              </a:defRPr>
-            </a:pPr>
-            <a:r>
-              <a:t>■ 大学での研究：</a:t>
             </a:r>
           </a:p>
           <a:p>
@@ -4492,47 +4464,47 @@
               <a:spcBef>
                 <a:spcPts val="600"/>
               </a:spcBef>
-              <a:defRPr sz="1300" b="0">
-                <a:solidFill>
-                  <a:srgbClr val="333333"/>
-                </a:solidFill>
-                <a:latin typeface="BIZ UDPGothic"/>
-              </a:defRPr>
-            </a:pPr>
-            <a:r>
-              <a:t>遺伝子ネットワークモデルの制御</a:t>
+              <a:defRPr sz="1800" b="0">
+                <a:solidFill>
+                  <a:srgbClr val="222222"/>
+                </a:solidFill>
+                <a:latin typeface="BIZ UDPGothic"/>
+              </a:defRPr>
+            </a:pPr>
+            <a:r>
+              <a:t>③関西の雰囲気を知る</a:t>
             </a:r>
           </a:p>
           <a:p>
             <a:pPr>
               <a:spcBef>
-                <a:spcPts val="400"/>
+                <a:spcPts val="2600"/>
               </a:spcBef>
-              <a:defRPr sz="1300" b="0">
-                <a:solidFill>
-                  <a:srgbClr val="333333"/>
-                </a:solidFill>
-                <a:latin typeface="BIZ UDPGothic"/>
-              </a:defRPr>
-            </a:pPr>
-            <a:r>
-              <a:t>病気を治すための投薬順序の最適化</a:t>
+              <a:defRPr sz="2000" b="1">
+                <a:solidFill>
+                  <a:srgbClr val="111111"/>
+                </a:solidFill>
+                <a:latin typeface="BIZ UDPGothic"/>
+              </a:defRPr>
+            </a:pPr>
+            <a:r>
+              <a:t>■ 大学での研究：</a:t>
             </a:r>
           </a:p>
           <a:p>
             <a:pPr>
               <a:spcBef>
-                <a:spcPts val="2200"/>
+                <a:spcPts val="800"/>
               </a:spcBef>
-              <a:defRPr sz="1400" b="1">
-                <a:solidFill>
-                  <a:srgbClr val="111111"/>
-                </a:solidFill>
-                <a:latin typeface="BIZ UDPGothic"/>
-              </a:defRPr>
-            </a:pPr>
-            <a:r>
-              <a:t>■ 趣味：</a:t>
+              <a:defRPr sz="1800" b="0">
+                <a:solidFill>
+                  <a:srgbClr val="222222"/>
+                </a:solidFill>
+                <a:latin typeface="BIZ UDPGothic"/>
+              </a:defRPr>
+            </a:pPr>
+            <a:r>
+              <a:t>遺伝子ネットワークモデルの制御</a:t>
             </a:r>
           </a:p>
           <a:p>
@@ -4540,9 +4512,41 @@
               <a:spcBef>
                 <a:spcPts val="600"/>
               </a:spcBef>
-              <a:defRPr sz="1300" b="0">
-                <a:solidFill>
-                  <a:srgbClr val="333333"/>
+              <a:defRPr sz="1800" b="0">
+                <a:solidFill>
+                  <a:srgbClr val="222222"/>
+                </a:solidFill>
+                <a:latin typeface="BIZ UDPGothic"/>
+              </a:defRPr>
+            </a:pPr>
+            <a:r>
+              <a:t>病気を治すための投薬順序の最適化</a:t>
+            </a:r>
+          </a:p>
+          <a:p>
+            <a:pPr>
+              <a:spcBef>
+                <a:spcPts val="2600"/>
+              </a:spcBef>
+              <a:defRPr sz="2000" b="1">
+                <a:solidFill>
+                  <a:srgbClr val="111111"/>
+                </a:solidFill>
+                <a:latin typeface="BIZ UDPGothic"/>
+              </a:defRPr>
+            </a:pPr>
+            <a:r>
+              <a:t>■ 趣味：</a:t>
+            </a:r>
+          </a:p>
+          <a:p>
+            <a:pPr>
+              <a:spcBef>
+                <a:spcPts val="800"/>
+              </a:spcBef>
+              <a:defRPr sz="1800" b="0">
+                <a:solidFill>
+                  <a:srgbClr val="222222"/>
                 </a:solidFill>
                 <a:latin typeface="BIZ UDPGothic"/>
               </a:defRPr>
@@ -4580,7 +4584,7 @@
         <p:spPr>
           <a:xfrm>
             <a:off x="0" y="0"/>
-            <a:ext cx="12191695" cy="530352"/>
+            <a:ext cx="12191695" cy="585216"/>
           </a:xfrm>
           <a:prstGeom prst="rect">
             <a:avLst/>
@@ -4623,7 +4627,7 @@
         <p:spPr>
           <a:xfrm>
             <a:off x="301752" y="73152"/>
-            <a:ext cx="9144000" cy="411480"/>
+            <a:ext cx="9144000" cy="457200"/>
           </a:xfrm>
           <a:prstGeom prst="rect">
             <a:avLst/>
@@ -4637,7 +4641,7 @@
           <a:lstStyle/>
           <a:p>
             <a:pPr>
-              <a:defRPr sz="1800" b="1">
+              <a:defRPr sz="2000" b="1">
                 <a:solidFill>
                   <a:srgbClr val="FFFFFF"/>
                 </a:solidFill>
@@ -4658,8 +4662,8 @@
         </p:nvSpPr>
         <p:spPr>
           <a:xfrm>
-            <a:off x="10789920" y="128016"/>
-            <a:ext cx="484632" cy="274320"/>
+            <a:off x="10698480" y="137160"/>
+            <a:ext cx="530352" cy="301752"/>
           </a:xfrm>
           <a:prstGeom prst="roundRect">
             <a:avLst/>
@@ -4692,7 +4696,7 @@
           <a:lstStyle/>
           <a:p>
             <a:pPr algn="ctr">
-              <a:defRPr sz="1100" i="1">
+              <a:defRPr sz="1200" i="1" b="1">
                 <a:solidFill>
                   <a:srgbClr val="E8F1F8"/>
                 </a:solidFill>
@@ -4714,7 +4718,7 @@
         <p:spPr>
           <a:xfrm>
             <a:off x="11430000" y="73152"/>
-            <a:ext cx="548640" cy="411480"/>
+            <a:ext cx="548640" cy="457200"/>
           </a:xfrm>
           <a:prstGeom prst="rect">
             <a:avLst/>
@@ -4728,7 +4732,7 @@
           <a:lstStyle/>
           <a:p>
             <a:pPr algn="ctr">
-              <a:defRPr sz="1800" b="1">
+              <a:defRPr sz="2000" b="1">
                 <a:solidFill>
                   <a:srgbClr val="FFFFFF"/>
                 </a:solidFill>
@@ -4764,7 +4768,7 @@
           <a:lstStyle/>
           <a:p>
             <a:pPr algn="r">
-              <a:defRPr sz="800">
+              <a:defRPr sz="900">
                 <a:solidFill>
                   <a:srgbClr val="666666"/>
                 </a:solidFill>
@@ -4785,8 +4789,8 @@
         </p:nvSpPr>
         <p:spPr>
           <a:xfrm>
-            <a:off x="731520" y="868680"/>
-            <a:ext cx="10698480" cy="2011680"/>
+            <a:off x="640080" y="822960"/>
+            <a:ext cx="10789920" cy="2103120"/>
           </a:xfrm>
           <a:prstGeom prst="rect">
             <a:avLst/>
@@ -4803,7 +4807,7 @@
               <a:spcBef>
                 <a:spcPts val="0"/>
               </a:spcBef>
-              <a:defRPr sz="1400" b="1">
+              <a:defRPr sz="2000" b="1">
                 <a:solidFill>
                   <a:srgbClr val="111111"/>
                 </a:solidFill>
@@ -4819,15 +4823,15 @@
               <a:spcBef>
                 <a:spcPts val="600"/>
               </a:spcBef>
-              <a:defRPr sz="1250" b="0">
-                <a:solidFill>
-                  <a:srgbClr val="333333"/>
-                </a:solidFill>
-                <a:latin typeface="BIZ UDPGothic"/>
-              </a:defRPr>
-            </a:pPr>
-            <a:r>
-              <a:t>・近年、気候変動への対応やカーボンニュートラルの実現に向け、ESG※1投資が世界的に拡大している</a:t>
+              <a:defRPr sz="1700" b="0">
+                <a:solidFill>
+                  <a:srgbClr val="222222"/>
+                </a:solidFill>
+                <a:latin typeface="BIZ UDPGothic"/>
+              </a:defRPr>
+            </a:pPr>
+            <a:r>
+              <a:t>・近年、気候変動への対応やカーボンニュートラル実現に向け、ESG※1投資が世界的に拡大している</a:t>
             </a:r>
           </a:p>
           <a:p>
@@ -4835,9 +4839,9 @@
               <a:spcBef>
                 <a:spcPts val="400"/>
               </a:spcBef>
-              <a:defRPr sz="1250" b="0">
-                <a:solidFill>
-                  <a:srgbClr val="333333"/>
+              <a:defRPr sz="1700" b="0">
+                <a:solidFill>
+                  <a:srgbClr val="222222"/>
                 </a:solidFill>
                 <a:latin typeface="BIZ UDPGothic"/>
               </a:defRPr>
@@ -4857,7 +4861,7 @@
         <p:spPr>
           <a:xfrm>
             <a:off x="9144000" y="1280160"/>
-            <a:ext cx="2560320" cy="914400"/>
+            <a:ext cx="2560320" cy="1005840"/>
           </a:xfrm>
           <a:prstGeom prst="rect">
             <a:avLst/>
@@ -4874,7 +4878,7 @@
               <a:spcBef>
                 <a:spcPts val="0"/>
               </a:spcBef>
-              <a:defRPr sz="800" b="0">
+              <a:defRPr sz="950" b="0">
                 <a:solidFill>
                   <a:srgbClr val="666666"/>
                 </a:solidFill>
@@ -4903,8 +4907,8 @@
         </p:nvSpPr>
         <p:spPr>
           <a:xfrm>
-            <a:off x="5852160" y="1828800"/>
-            <a:ext cx="320040" cy="320040"/>
+            <a:off x="5852160" y="1874519"/>
+            <a:ext cx="347472" cy="347472"/>
           </a:xfrm>
           <a:prstGeom prst="downArrow">
             <a:avLst/>
@@ -4946,8 +4950,8 @@
         </p:nvSpPr>
         <p:spPr>
           <a:xfrm>
-            <a:off x="2103120" y="2240280"/>
-            <a:ext cx="7955279" cy="502920"/>
+            <a:off x="1645920" y="2304288"/>
+            <a:ext cx="8869680" cy="566928"/>
           </a:xfrm>
           <a:prstGeom prst="roundRect">
             <a:avLst/>
@@ -4955,7 +4959,7 @@
           <a:solidFill>
             <a:srgbClr val="EDF5FB"/>
           </a:solidFill>
-          <a:ln>
+          <a:ln w="19050">
             <a:solidFill>
               <a:srgbClr val="7BA4C7"/>
             </a:solidFill>
@@ -4980,7 +4984,7 @@
           <a:lstStyle/>
           <a:p>
             <a:pPr algn="ctr">
-              <a:defRPr sz="1300" b="1">
+              <a:defRPr sz="1800" b="1">
                 <a:solidFill>
                   <a:srgbClr val="113355"/>
                 </a:solidFill>
@@ -5001,8 +5005,8 @@
         </p:nvSpPr>
         <p:spPr>
           <a:xfrm>
-            <a:off x="731520" y="3017520"/>
-            <a:ext cx="10698480" cy="1371600"/>
+            <a:off x="640080" y="3063240"/>
+            <a:ext cx="10789920" cy="1463040"/>
           </a:xfrm>
           <a:prstGeom prst="rect">
             <a:avLst/>
@@ -5019,7 +5023,7 @@
               <a:spcBef>
                 <a:spcPts val="0"/>
               </a:spcBef>
-              <a:defRPr sz="1400" b="1">
+              <a:defRPr sz="2000" b="1">
                 <a:solidFill>
                   <a:srgbClr val="111111"/>
                 </a:solidFill>
@@ -5035,9 +5039,9 @@
               <a:spcBef>
                 <a:spcPts val="600"/>
               </a:spcBef>
-              <a:defRPr sz="1250" b="0">
-                <a:solidFill>
-                  <a:srgbClr val="333333"/>
+              <a:defRPr sz="1700" b="0">
+                <a:solidFill>
+                  <a:srgbClr val="222222"/>
                 </a:solidFill>
                 <a:latin typeface="BIZ UDPGothic"/>
               </a:defRPr>
@@ -5051,9 +5055,9 @@
               <a:spcBef>
                 <a:spcPts val="400"/>
               </a:spcBef>
-              <a:defRPr sz="1250" b="0">
-                <a:solidFill>
-                  <a:srgbClr val="333333"/>
+              <a:defRPr sz="1700" b="0">
+                <a:solidFill>
+                  <a:srgbClr val="222222"/>
                 </a:solidFill>
                 <a:latin typeface="BIZ UDPGothic"/>
               </a:defRPr>
@@ -5072,8 +5076,8 @@
         </p:nvSpPr>
         <p:spPr>
           <a:xfrm>
-            <a:off x="2377440" y="4297680"/>
-            <a:ext cx="1828800" cy="822960"/>
+            <a:off x="2011680" y="4434840"/>
+            <a:ext cx="2103120" cy="868680"/>
           </a:xfrm>
           <a:prstGeom prst="roundRect">
             <a:avLst/>
@@ -5081,7 +5085,7 @@
           <a:solidFill>
             <a:srgbClr val="D9EBF7"/>
           </a:solidFill>
-          <a:ln w="19050">
+          <a:ln w="22860">
             <a:solidFill>
               <a:srgbClr val="4A90E2"/>
             </a:solidFill>
@@ -5106,7 +5110,7 @@
           <a:lstStyle/>
           <a:p>
             <a:pPr algn="ctr">
-              <a:defRPr sz="1250" b="1">
+              <a:defRPr sz="1650" b="1">
                 <a:solidFill>
                   <a:srgbClr val="0B3968"/>
                 </a:solidFill>
@@ -5131,8 +5135,8 @@
         </p:nvSpPr>
         <p:spPr>
           <a:xfrm>
-            <a:off x="4480560" y="4572000"/>
-            <a:ext cx="457200" cy="274320"/>
+            <a:off x="4389120" y="4709160"/>
+            <a:ext cx="502920" cy="320040"/>
           </a:xfrm>
           <a:prstGeom prst="rightArrow">
             <a:avLst/>
@@ -5174,8 +5178,8 @@
         </p:nvSpPr>
         <p:spPr>
           <a:xfrm>
-            <a:off x="5212080" y="4297680"/>
-            <a:ext cx="1828800" cy="822960"/>
+            <a:off x="5120640" y="4434840"/>
+            <a:ext cx="2103120" cy="868680"/>
           </a:xfrm>
           <a:prstGeom prst="roundRect">
             <a:avLst/>
@@ -5183,7 +5187,7 @@
           <a:solidFill>
             <a:srgbClr val="D9EBF7"/>
           </a:solidFill>
-          <a:ln w="19050">
+          <a:ln w="22860">
             <a:solidFill>
               <a:srgbClr val="4A90E2"/>
             </a:solidFill>
@@ -5208,7 +5212,7 @@
           <a:lstStyle/>
           <a:p>
             <a:pPr algn="ctr">
-              <a:defRPr sz="1250" b="1">
+              <a:defRPr sz="1650" b="1">
                 <a:solidFill>
                   <a:srgbClr val="0B3968"/>
                 </a:solidFill>
@@ -5233,8 +5237,8 @@
         </p:nvSpPr>
         <p:spPr>
           <a:xfrm>
-            <a:off x="7315200" y="4572000"/>
-            <a:ext cx="457200" cy="274320"/>
+            <a:off x="7498079" y="4709160"/>
+            <a:ext cx="502920" cy="320040"/>
           </a:xfrm>
           <a:prstGeom prst="rightArrow">
             <a:avLst/>
@@ -5276,8 +5280,8 @@
         </p:nvSpPr>
         <p:spPr>
           <a:xfrm>
-            <a:off x="8046720" y="4297680"/>
-            <a:ext cx="1828800" cy="822960"/>
+            <a:off x="8229600" y="4434840"/>
+            <a:ext cx="2103120" cy="868680"/>
           </a:xfrm>
           <a:prstGeom prst="roundRect">
             <a:avLst/>
@@ -5285,7 +5289,7 @@
           <a:solidFill>
             <a:srgbClr val="D9EBF7"/>
           </a:solidFill>
-          <a:ln w="19050">
+          <a:ln w="22860">
             <a:solidFill>
               <a:srgbClr val="4A90E2"/>
             </a:solidFill>
@@ -5310,7 +5314,7 @@
           <a:lstStyle/>
           <a:p>
             <a:pPr algn="ctr">
-              <a:defRPr sz="1250" b="1">
+              <a:defRPr sz="1650" b="1">
                 <a:solidFill>
                   <a:srgbClr val="0B3968"/>
                 </a:solidFill>
@@ -5354,7 +5358,7 @@
         <p:spPr>
           <a:xfrm>
             <a:off x="0" y="0"/>
-            <a:ext cx="12191695" cy="530352"/>
+            <a:ext cx="12191695" cy="585216"/>
           </a:xfrm>
           <a:prstGeom prst="rect">
             <a:avLst/>
@@ -5397,7 +5401,7 @@
         <p:spPr>
           <a:xfrm>
             <a:off x="301752" y="73152"/>
-            <a:ext cx="9144000" cy="411480"/>
+            <a:ext cx="9144000" cy="457200"/>
           </a:xfrm>
           <a:prstGeom prst="rect">
             <a:avLst/>
@@ -5411,7 +5415,7 @@
           <a:lstStyle/>
           <a:p>
             <a:pPr>
-              <a:defRPr sz="1800" b="1">
+              <a:defRPr sz="2000" b="1">
                 <a:solidFill>
                   <a:srgbClr val="FFFFFF"/>
                 </a:solidFill>
@@ -5432,8 +5436,8 @@
         </p:nvSpPr>
         <p:spPr>
           <a:xfrm>
-            <a:off x="10789920" y="128016"/>
-            <a:ext cx="484632" cy="274320"/>
+            <a:off x="10698480" y="137160"/>
+            <a:ext cx="530352" cy="301752"/>
           </a:xfrm>
           <a:prstGeom prst="roundRect">
             <a:avLst/>
@@ -5466,7 +5470,7 @@
           <a:lstStyle/>
           <a:p>
             <a:pPr algn="ctr">
-              <a:defRPr sz="1100" i="1">
+              <a:defRPr sz="1200" i="1" b="1">
                 <a:solidFill>
                   <a:srgbClr val="E8F1F8"/>
                 </a:solidFill>
@@ -5488,7 +5492,7 @@
         <p:spPr>
           <a:xfrm>
             <a:off x="11430000" y="73152"/>
-            <a:ext cx="548640" cy="411480"/>
+            <a:ext cx="548640" cy="457200"/>
           </a:xfrm>
           <a:prstGeom prst="rect">
             <a:avLst/>
@@ -5502,7 +5506,7 @@
           <a:lstStyle/>
           <a:p>
             <a:pPr algn="ctr">
-              <a:defRPr sz="1800" b="1">
+              <a:defRPr sz="2000" b="1">
                 <a:solidFill>
                   <a:srgbClr val="FFFFFF"/>
                 </a:solidFill>
@@ -5538,7 +5542,7 @@
           <a:lstStyle/>
           <a:p>
             <a:pPr algn="r">
-              <a:defRPr sz="800">
+              <a:defRPr sz="900">
                 <a:solidFill>
                   <a:srgbClr val="666666"/>
                 </a:solidFill>
@@ -5559,8 +5563,8 @@
         </p:nvSpPr>
         <p:spPr>
           <a:xfrm>
-            <a:off x="640080" y="868680"/>
-            <a:ext cx="4389120" cy="4389120"/>
+            <a:off x="548640" y="822960"/>
+            <a:ext cx="4572000" cy="4572000"/>
           </a:xfrm>
           <a:prstGeom prst="rect">
             <a:avLst/>
@@ -5577,7 +5581,7 @@
               <a:spcBef>
                 <a:spcPts val="0"/>
               </a:spcBef>
-              <a:defRPr sz="1350" b="1">
+              <a:defRPr sz="2000" b="1">
                 <a:solidFill>
                   <a:srgbClr val="111111"/>
                 </a:solidFill>
@@ -5591,11 +5595,11 @@
           <a:p>
             <a:pPr>
               <a:spcBef>
-                <a:spcPts val="400"/>
+                <a:spcPts val="600"/>
               </a:spcBef>
-              <a:defRPr sz="1200" b="0">
-                <a:solidFill>
-                  <a:srgbClr val="333333"/>
+              <a:defRPr sz="1700" b="0">
+                <a:solidFill>
+                  <a:srgbClr val="222222"/>
                 </a:solidFill>
                 <a:latin typeface="BIZ UDPGothic"/>
               </a:defRPr>
@@ -5611,9 +5615,9 @@
           <a:p>
             <a:pPr>
               <a:spcBef>
-                <a:spcPts val="1000"/>
+                <a:spcPts val="1400"/>
               </a:spcBef>
-              <a:defRPr sz="1250" b="1">
+              <a:defRPr sz="1800" b="1">
                 <a:solidFill>
                   <a:srgbClr val="111111"/>
                 </a:solidFill>
@@ -5627,11 +5631,11 @@
           <a:p>
             <a:pPr>
               <a:spcBef>
-                <a:spcPts val="200"/>
+                <a:spcPts val="300"/>
               </a:spcBef>
-              <a:defRPr sz="1200" b="0">
-                <a:solidFill>
-                  <a:srgbClr val="333333"/>
+              <a:defRPr sz="1650" b="0">
+                <a:solidFill>
+                  <a:srgbClr val="222222"/>
                 </a:solidFill>
                 <a:latin typeface="BIZ UDPGothic"/>
               </a:defRPr>
@@ -5643,9 +5647,9 @@
           <a:p>
             <a:pPr>
               <a:spcBef>
-                <a:spcPts val="1000"/>
+                <a:spcPts val="1400"/>
               </a:spcBef>
-              <a:defRPr sz="1250" b="1">
+              <a:defRPr sz="1800" b="1">
                 <a:solidFill>
                   <a:srgbClr val="111111"/>
                 </a:solidFill>
@@ -5659,11 +5663,11 @@
           <a:p>
             <a:pPr>
               <a:spcBef>
-                <a:spcPts val="200"/>
+                <a:spcPts val="300"/>
               </a:spcBef>
-              <a:defRPr sz="1200" b="0">
-                <a:solidFill>
-                  <a:srgbClr val="333333"/>
+              <a:defRPr sz="1650" b="0">
+                <a:solidFill>
+                  <a:srgbClr val="222222"/>
                 </a:solidFill>
                 <a:latin typeface="BIZ UDPGothic"/>
               </a:defRPr>
@@ -5675,9 +5679,9 @@
           <a:p>
             <a:pPr>
               <a:spcBef>
-                <a:spcPts val="1000"/>
+                <a:spcPts val="1400"/>
               </a:spcBef>
-              <a:defRPr sz="1250" b="1">
+              <a:defRPr sz="1800" b="1">
                 <a:solidFill>
                   <a:srgbClr val="111111"/>
                 </a:solidFill>
@@ -5691,11 +5695,11 @@
           <a:p>
             <a:pPr>
               <a:spcBef>
-                <a:spcPts val="200"/>
+                <a:spcPts val="300"/>
               </a:spcBef>
-              <a:defRPr sz="1200" b="0">
-                <a:solidFill>
-                  <a:srgbClr val="333333"/>
+              <a:defRPr sz="1650" b="0">
+                <a:solidFill>
+                  <a:srgbClr val="222222"/>
                 </a:solidFill>
                 <a:latin typeface="BIZ UDPGothic"/>
               </a:defRPr>
@@ -5718,8 +5722,8 @@
         </p:nvSpPr>
         <p:spPr>
           <a:xfrm>
-            <a:off x="640080" y="5486400"/>
-            <a:ext cx="10789920" cy="731520"/>
+            <a:off x="548640" y="5486400"/>
+            <a:ext cx="10972800" cy="731520"/>
           </a:xfrm>
           <a:prstGeom prst="rect">
             <a:avLst/>
@@ -5733,7 +5737,7 @@
           <a:lstStyle/>
           <a:p>
             <a:pPr>
-              <a:defRPr sz="1200" b="1">
+              <a:defRPr sz="1700" b="1">
                 <a:solidFill>
                   <a:srgbClr val="111111"/>
                 </a:solidFill>
@@ -5763,7 +5767,7 @@
         <p:spPr>
           <a:xfrm>
             <a:off x="4846320" y="731520"/>
-            <a:ext cx="6858000" cy="4480560"/>
+            <a:ext cx="6858000" cy="4572000"/>
           </a:xfrm>
           <a:prstGeom prst="rect">
             <a:avLst/>
@@ -5797,7 +5801,7 @@
         <p:spPr>
           <a:xfrm>
             <a:off x="0" y="0"/>
-            <a:ext cx="12191695" cy="530352"/>
+            <a:ext cx="12191695" cy="585216"/>
           </a:xfrm>
           <a:prstGeom prst="rect">
             <a:avLst/>
@@ -5840,7 +5844,7 @@
         <p:spPr>
           <a:xfrm>
             <a:off x="301752" y="73152"/>
-            <a:ext cx="9144000" cy="411480"/>
+            <a:ext cx="9144000" cy="457200"/>
           </a:xfrm>
           <a:prstGeom prst="rect">
             <a:avLst/>
@@ -5854,7 +5858,7 @@
           <a:lstStyle/>
           <a:p>
             <a:pPr>
-              <a:defRPr sz="1800" b="1">
+              <a:defRPr sz="2000" b="1">
                 <a:solidFill>
                   <a:srgbClr val="FFFFFF"/>
                 </a:solidFill>
@@ -5875,8 +5879,8 @@
         </p:nvSpPr>
         <p:spPr>
           <a:xfrm>
-            <a:off x="10789920" y="128016"/>
-            <a:ext cx="484632" cy="274320"/>
+            <a:off x="10698480" y="137160"/>
+            <a:ext cx="530352" cy="301752"/>
           </a:xfrm>
           <a:prstGeom prst="roundRect">
             <a:avLst/>
@@ -5909,7 +5913,7 @@
           <a:lstStyle/>
           <a:p>
             <a:pPr algn="ctr">
-              <a:defRPr sz="1100" i="1">
+              <a:defRPr sz="1200" i="1" b="1">
                 <a:solidFill>
                   <a:srgbClr val="E8F1F8"/>
                 </a:solidFill>
@@ -5931,7 +5935,7 @@
         <p:spPr>
           <a:xfrm>
             <a:off x="11430000" y="73152"/>
-            <a:ext cx="548640" cy="411480"/>
+            <a:ext cx="548640" cy="457200"/>
           </a:xfrm>
           <a:prstGeom prst="rect">
             <a:avLst/>
@@ -5945,7 +5949,7 @@
           <a:lstStyle/>
           <a:p>
             <a:pPr algn="ctr">
-              <a:defRPr sz="1800" b="1">
+              <a:defRPr sz="2000" b="1">
                 <a:solidFill>
                   <a:srgbClr val="FFFFFF"/>
                 </a:solidFill>
@@ -5981,7 +5985,7 @@
           <a:lstStyle/>
           <a:p>
             <a:pPr algn="r">
-              <a:defRPr sz="800">
+              <a:defRPr sz="900">
                 <a:solidFill>
                   <a:srgbClr val="666666"/>
                 </a:solidFill>
@@ -6002,8 +6006,8 @@
         </p:nvSpPr>
         <p:spPr>
           <a:xfrm>
-            <a:off x="640080" y="868680"/>
-            <a:ext cx="4572000" cy="3474720"/>
+            <a:off x="548640" y="822960"/>
+            <a:ext cx="4754880" cy="3657600"/>
           </a:xfrm>
           <a:prstGeom prst="rect">
             <a:avLst/>
@@ -6020,7 +6024,7 @@
               <a:spcBef>
                 <a:spcPts val="0"/>
               </a:spcBef>
-              <a:defRPr sz="1350" b="1">
+              <a:defRPr sz="2000" b="1">
                 <a:solidFill>
                   <a:srgbClr val="111111"/>
                 </a:solidFill>
@@ -6034,17 +6038,17 @@
           <a:p>
             <a:pPr>
               <a:spcBef>
-                <a:spcPts val="400"/>
+                <a:spcPts val="600"/>
               </a:spcBef>
-              <a:defRPr sz="1200" b="0">
-                <a:solidFill>
-                  <a:srgbClr val="333333"/>
-                </a:solidFill>
-                <a:latin typeface="BIZ UDPGothic"/>
-              </a:defRPr>
-            </a:pPr>
-            <a:r>
-              <a:t>・対象期間:2025/8/19〜8/30</a:t>
+              <a:defRPr sz="1700" b="0">
+                <a:solidFill>
+                  <a:srgbClr val="222222"/>
+                </a:solidFill>
+                <a:latin typeface="BIZ UDPGothic"/>
+              </a:defRPr>
+            </a:pPr>
+            <a:r>
+              <a:t>・対象期間: 2025/8/19〜8/30</a:t>
             </a:r>
             <a:br/>
             <a:r>
@@ -6056,15 +6060,15 @@
             </a:r>
             <a:br/>
             <a:r>
-              <a:t>・6:30〜7:00に設定温度へ到達</a:t>
+              <a:t>・6:30〜7:00 に設定温度へ到達</a:t>
             </a:r>
           </a:p>
           <a:p>
             <a:pPr>
               <a:spcBef>
-                <a:spcPts val="1200"/>
+                <a:spcPts val="1600"/>
               </a:spcBef>
-              <a:defRPr sz="1350" b="1">
+              <a:defRPr sz="2000" b="1">
                 <a:solidFill>
                   <a:srgbClr val="111111"/>
                 </a:solidFill>
@@ -6078,11 +6082,11 @@
           <a:p>
             <a:pPr>
               <a:spcBef>
-                <a:spcPts val="400"/>
+                <a:spcPts val="600"/>
               </a:spcBef>
-              <a:defRPr sz="1200" b="0">
-                <a:solidFill>
-                  <a:srgbClr val="333333"/>
+              <a:defRPr sz="1700" b="0">
+                <a:solidFill>
+                  <a:srgbClr val="222222"/>
                 </a:solidFill>
                 <a:latin typeface="BIZ UDPGothic"/>
               </a:defRPr>
@@ -6117,8 +6121,8 @@
         </p:nvSpPr>
         <p:spPr>
           <a:xfrm>
-            <a:off x="914400" y="4297680"/>
-            <a:ext cx="3657600" cy="1188720"/>
+            <a:off x="731520" y="4297680"/>
+            <a:ext cx="4206240" cy="1325880"/>
           </a:xfrm>
           <a:prstGeom prst="roundRect">
             <a:avLst/>
@@ -6126,7 +6130,7 @@
           <a:solidFill>
             <a:srgbClr val="EDF5FB"/>
           </a:solidFill>
-          <a:ln w="19050">
+          <a:ln w="22860">
             <a:solidFill>
               <a:srgbClr val="7BA4C7"/>
             </a:solidFill>
@@ -6151,7 +6155,7 @@
           <a:lstStyle/>
           <a:p>
             <a:pPr algn="ctr">
-              <a:defRPr sz="1250" b="1">
+              <a:defRPr sz="1700" b="1">
                 <a:solidFill>
                   <a:srgbClr val="111111"/>
                 </a:solidFill>
@@ -6169,9 +6173,9 @@
           <a:p>
             <a:pPr algn="ctr">
               <a:spcBef>
-                <a:spcPts val="400"/>
+                <a:spcPts val="600"/>
               </a:spcBef>
-              <a:defRPr sz="1400" b="1">
+              <a:defRPr sz="1900" b="1">
                 <a:solidFill>
                   <a:srgbClr val="C8102E"/>
                 </a:solidFill>
@@ -6200,8 +6204,8 @@
         </p:blipFill>
         <p:spPr>
           <a:xfrm>
-            <a:off x="5212080" y="777240"/>
-            <a:ext cx="6583680" cy="5303520"/>
+            <a:off x="5120640" y="777240"/>
+            <a:ext cx="6675120" cy="5486400"/>
           </a:xfrm>
           <a:prstGeom prst="rect">
             <a:avLst/>
@@ -6235,7 +6239,7 @@
         <p:spPr>
           <a:xfrm>
             <a:off x="0" y="0"/>
-            <a:ext cx="12191695" cy="530352"/>
+            <a:ext cx="12191695" cy="585216"/>
           </a:xfrm>
           <a:prstGeom prst="rect">
             <a:avLst/>
@@ -6278,7 +6282,7 @@
         <p:spPr>
           <a:xfrm>
             <a:off x="301752" y="73152"/>
-            <a:ext cx="9144000" cy="411480"/>
+            <a:ext cx="9144000" cy="457200"/>
           </a:xfrm>
           <a:prstGeom prst="rect">
             <a:avLst/>
@@ -6292,7 +6296,7 @@
           <a:lstStyle/>
           <a:p>
             <a:pPr>
-              <a:defRPr sz="1800" b="1">
+              <a:defRPr sz="2000" b="1">
                 <a:solidFill>
                   <a:srgbClr val="FFFFFF"/>
                 </a:solidFill>
@@ -6313,8 +6317,8 @@
         </p:nvSpPr>
         <p:spPr>
           <a:xfrm>
-            <a:off x="10789920" y="128016"/>
-            <a:ext cx="484632" cy="274320"/>
+            <a:off x="10698480" y="137160"/>
+            <a:ext cx="530352" cy="301752"/>
           </a:xfrm>
           <a:prstGeom prst="roundRect">
             <a:avLst/>
@@ -6347,7 +6351,7 @@
           <a:lstStyle/>
           <a:p>
             <a:pPr algn="ctr">
-              <a:defRPr sz="1100" i="1">
+              <a:defRPr sz="1200" i="1" b="1">
                 <a:solidFill>
                   <a:srgbClr val="E8F1F8"/>
                 </a:solidFill>
@@ -6369,7 +6373,7 @@
         <p:spPr>
           <a:xfrm>
             <a:off x="11430000" y="73152"/>
-            <a:ext cx="548640" cy="411480"/>
+            <a:ext cx="548640" cy="457200"/>
           </a:xfrm>
           <a:prstGeom prst="rect">
             <a:avLst/>
@@ -6383,7 +6387,7 @@
           <a:lstStyle/>
           <a:p>
             <a:pPr algn="ctr">
-              <a:defRPr sz="1800" b="1">
+              <a:defRPr sz="2000" b="1">
                 <a:solidFill>
                   <a:srgbClr val="FFFFFF"/>
                 </a:solidFill>
@@ -6419,7 +6423,7 @@
           <a:lstStyle/>
           <a:p>
             <a:pPr algn="r">
-              <a:defRPr sz="800">
+              <a:defRPr sz="900">
                 <a:solidFill>
                   <a:srgbClr val="666666"/>
                 </a:solidFill>
@@ -6440,8 +6444,8 @@
         </p:nvSpPr>
         <p:spPr>
           <a:xfrm>
-            <a:off x="640080" y="868680"/>
-            <a:ext cx="10789920" cy="2926080"/>
+            <a:off x="548640" y="822960"/>
+            <a:ext cx="10972800" cy="3108960"/>
           </a:xfrm>
           <a:prstGeom prst="rect">
             <a:avLst/>
@@ -6458,7 +6462,7 @@
               <a:spcBef>
                 <a:spcPts val="0"/>
               </a:spcBef>
-              <a:defRPr sz="1350" b="1">
+              <a:defRPr sz="2000" b="1">
                 <a:solidFill>
                   <a:srgbClr val="111111"/>
                 </a:solidFill>
@@ -6472,9 +6476,9 @@
           <a:p>
             <a:pPr>
               <a:spcBef>
-                <a:spcPts val="400"/>
+                <a:spcPts val="600"/>
               </a:spcBef>
-              <a:defRPr sz="1250" b="1">
+              <a:defRPr sz="1800" b="1">
                 <a:solidFill>
                   <a:srgbClr val="111111"/>
                 </a:solidFill>
@@ -6488,11 +6492,11 @@
           <a:p>
             <a:pPr>
               <a:spcBef>
-                <a:spcPts val="200"/>
+                <a:spcPts val="300"/>
               </a:spcBef>
-              <a:defRPr sz="1200" b="0">
-                <a:solidFill>
-                  <a:srgbClr val="333333"/>
+              <a:defRPr sz="1650" b="0">
+                <a:solidFill>
+                  <a:srgbClr val="222222"/>
                 </a:solidFill>
                 <a:latin typeface="BIZ UDPGothic"/>
               </a:defRPr>
@@ -6508,9 +6512,9 @@
           <a:p>
             <a:pPr>
               <a:spcBef>
-                <a:spcPts val="1000"/>
+                <a:spcPts val="1400"/>
               </a:spcBef>
-              <a:defRPr sz="1250" b="1">
+              <a:defRPr sz="1800" b="1">
                 <a:solidFill>
                   <a:srgbClr val="111111"/>
                 </a:solidFill>
@@ -6524,21 +6528,21 @@
           <a:p>
             <a:pPr>
               <a:spcBef>
-                <a:spcPts val="200"/>
+                <a:spcPts val="300"/>
               </a:spcBef>
-              <a:defRPr sz="1200" b="0">
-                <a:solidFill>
-                  <a:srgbClr val="333333"/>
-                </a:solidFill>
-                <a:latin typeface="BIZ UDPGothic"/>
-              </a:defRPr>
-            </a:pPr>
-            <a:r>
-              <a:t>・始業時に設定温度未達→快適性を損なう(高コスト)</a:t>
+              <a:defRPr sz="1650" b="0">
+                <a:solidFill>
+                  <a:srgbClr val="222222"/>
+                </a:solidFill>
+                <a:latin typeface="BIZ UDPGothic"/>
+              </a:defRPr>
+            </a:pPr>
+            <a:r>
+              <a:t>・始業時に設定温度未達 → 快適性を損なう(高コスト)</a:t>
             </a:r>
             <a:br/>
             <a:r>
-              <a:t>・過剰予冷→電力の無駄にはなるが、快適性は担保される(低コスト)</a:t>
+              <a:t>・過剰予冷 → 電力の無駄にはなるが、快適性は担保される(低コスト)</a:t>
             </a:r>
             <a:br/>
             <a:r>
@@ -6552,9 +6556,9 @@
           <a:p>
             <a:pPr>
               <a:spcBef>
-                <a:spcPts val="1600"/>
+                <a:spcPts val="2000"/>
               </a:spcBef>
-              <a:defRPr sz="1350" b="1">
+              <a:defRPr sz="2000" b="1">
                 <a:solidFill>
                   <a:srgbClr val="111111"/>
                 </a:solidFill>
@@ -6575,8 +6579,8 @@
         </p:nvSpPr>
         <p:spPr>
           <a:xfrm>
-            <a:off x="1371600" y="4572000"/>
-            <a:ext cx="9418320" cy="731520"/>
+            <a:off x="914400" y="4663440"/>
+            <a:ext cx="10332720" cy="822960"/>
           </a:xfrm>
           <a:prstGeom prst="rect">
             <a:avLst/>
@@ -6590,7 +6594,7 @@
           <a:lstStyle/>
           <a:p>
             <a:pPr algn="ctr">
-              <a:defRPr sz="1600" b="1">
+              <a:defRPr sz="1900" b="1">
                 <a:solidFill>
                   <a:srgbClr val="113355"/>
                 </a:solidFill>
@@ -6611,8 +6615,8 @@
         </p:nvSpPr>
         <p:spPr>
           <a:xfrm>
-            <a:off x="3017520" y="3931920"/>
-            <a:ext cx="2011680" cy="411480"/>
+            <a:off x="2651760" y="3931920"/>
+            <a:ext cx="2286000" cy="457200"/>
           </a:xfrm>
           <a:prstGeom prst="roundRect">
             <a:avLst/>
@@ -6620,7 +6624,7 @@
           <a:solidFill>
             <a:srgbClr val="FFFFFF"/>
           </a:solidFill>
-          <a:ln w="15240">
+          <a:ln w="19050">
             <a:solidFill>
               <a:srgbClr val="7BA4C7"/>
             </a:solidFill>
@@ -6645,7 +6649,7 @@
           <a:lstStyle/>
           <a:p>
             <a:pPr algn="ctr">
-              <a:defRPr sz="1100">
+              <a:defRPr sz="1500" b="1">
                 <a:solidFill>
                   <a:srgbClr val="111111"/>
                 </a:solidFill>
@@ -6666,8 +6670,8 @@
         </p:nvSpPr>
         <p:spPr>
           <a:xfrm>
-            <a:off x="5303520" y="5303520"/>
-            <a:ext cx="1828800" cy="411480"/>
+            <a:off x="5120640" y="5486400"/>
+            <a:ext cx="2011680" cy="457200"/>
           </a:xfrm>
           <a:prstGeom prst="roundRect">
             <a:avLst/>
@@ -6675,7 +6679,7 @@
           <a:solidFill>
             <a:srgbClr val="FFFFFF"/>
           </a:solidFill>
-          <a:ln w="15240">
+          <a:ln w="19050">
             <a:solidFill>
               <a:srgbClr val="7BA4C7"/>
             </a:solidFill>
@@ -6700,7 +6704,7 @@
           <a:lstStyle/>
           <a:p>
             <a:pPr algn="ctr">
-              <a:defRPr sz="1100">
+              <a:defRPr sz="1500" b="1">
                 <a:solidFill>
                   <a:srgbClr val="111111"/>
                 </a:solidFill>
@@ -6722,7 +6726,7 @@
         <p:spPr>
           <a:xfrm>
             <a:off x="8046720" y="3840480"/>
-            <a:ext cx="2011680" cy="502920"/>
+            <a:ext cx="2286000" cy="594360"/>
           </a:xfrm>
           <a:prstGeom prst="roundRect">
             <a:avLst/>
@@ -6730,7 +6734,7 @@
           <a:solidFill>
             <a:srgbClr val="FFFFFF"/>
           </a:solidFill>
-          <a:ln w="15240">
+          <a:ln w="19050">
             <a:solidFill>
               <a:srgbClr val="7BA4C7"/>
             </a:solidFill>
@@ -6755,7 +6759,7 @@
           <a:lstStyle/>
           <a:p>
             <a:pPr algn="ctr">
-              <a:defRPr sz="1100">
+              <a:defRPr sz="1500" b="1">
                 <a:solidFill>
                   <a:srgbClr val="111111"/>
                 </a:solidFill>
@@ -6799,7 +6803,7 @@
         <p:spPr>
           <a:xfrm>
             <a:off x="0" y="0"/>
-            <a:ext cx="12191695" cy="530352"/>
+            <a:ext cx="12191695" cy="585216"/>
           </a:xfrm>
           <a:prstGeom prst="rect">
             <a:avLst/>
@@ -6842,7 +6846,7 @@
         <p:spPr>
           <a:xfrm>
             <a:off x="301752" y="73152"/>
-            <a:ext cx="9144000" cy="411480"/>
+            <a:ext cx="9144000" cy="457200"/>
           </a:xfrm>
           <a:prstGeom prst="rect">
             <a:avLst/>
@@ -6856,7 +6860,7 @@
           <a:lstStyle/>
           <a:p>
             <a:pPr>
-              <a:defRPr sz="1800" b="1">
+              <a:defRPr sz="2000" b="1">
                 <a:solidFill>
                   <a:srgbClr val="FFFFFF"/>
                 </a:solidFill>
@@ -6877,8 +6881,8 @@
         </p:nvSpPr>
         <p:spPr>
           <a:xfrm>
-            <a:off x="10789920" y="128016"/>
-            <a:ext cx="484632" cy="274320"/>
+            <a:off x="10698480" y="137160"/>
+            <a:ext cx="530352" cy="301752"/>
           </a:xfrm>
           <a:prstGeom prst="roundRect">
             <a:avLst/>
@@ -6911,7 +6915,7 @@
           <a:lstStyle/>
           <a:p>
             <a:pPr algn="ctr">
-              <a:defRPr sz="1100" i="1">
+              <a:defRPr sz="1200" i="1" b="1">
                 <a:solidFill>
                   <a:srgbClr val="E8F1F8"/>
                 </a:solidFill>
@@ -6933,7 +6937,7 @@
         <p:spPr>
           <a:xfrm>
             <a:off x="11430000" y="73152"/>
-            <a:ext cx="548640" cy="411480"/>
+            <a:ext cx="548640" cy="457200"/>
           </a:xfrm>
           <a:prstGeom prst="rect">
             <a:avLst/>
@@ -6947,7 +6951,7 @@
           <a:lstStyle/>
           <a:p>
             <a:pPr algn="ctr">
-              <a:defRPr sz="1800" b="1">
+              <a:defRPr sz="2000" b="1">
                 <a:solidFill>
                   <a:srgbClr val="FFFFFF"/>
                 </a:solidFill>
@@ -6983,7 +6987,7 @@
           <a:lstStyle/>
           <a:p>
             <a:pPr algn="r">
-              <a:defRPr sz="800">
+              <a:defRPr sz="900">
                 <a:solidFill>
                   <a:srgbClr val="666666"/>
                 </a:solidFill>
@@ -7004,8 +7008,8 @@
         </p:nvSpPr>
         <p:spPr>
           <a:xfrm>
-            <a:off x="640080" y="868680"/>
-            <a:ext cx="6583680" cy="5029200"/>
+            <a:off x="548640" y="822960"/>
+            <a:ext cx="6766560" cy="5303520"/>
           </a:xfrm>
           <a:prstGeom prst="rect">
             <a:avLst/>
@@ -7022,7 +7026,7 @@
               <a:spcBef>
                 <a:spcPts val="0"/>
               </a:spcBef>
-              <a:defRPr sz="1350" b="1">
+              <a:defRPr sz="2000" b="1">
                 <a:solidFill>
                   <a:srgbClr val="111111"/>
                 </a:solidFill>
@@ -7036,9 +7040,9 @@
           <a:p>
             <a:pPr>
               <a:spcBef>
-                <a:spcPts val="400"/>
+                <a:spcPts val="600"/>
               </a:spcBef>
-              <a:defRPr sz="1250" b="1">
+              <a:defRPr sz="1800" b="1">
                 <a:solidFill>
                   <a:srgbClr val="111111"/>
                 </a:solidFill>
@@ -7052,11 +7056,11 @@
           <a:p>
             <a:pPr>
               <a:spcBef>
-                <a:spcPts val="200"/>
+                <a:spcPts val="300"/>
               </a:spcBef>
-              <a:defRPr sz="1200" b="0">
-                <a:solidFill>
-                  <a:srgbClr val="333333"/>
+              <a:defRPr sz="1650" b="0">
+                <a:solidFill>
+                  <a:srgbClr val="222222"/>
                 </a:solidFill>
                 <a:latin typeface="BIZ UDPGothic"/>
               </a:defRPr>
@@ -7076,9 +7080,9 @@
           <a:p>
             <a:pPr>
               <a:spcBef>
-                <a:spcPts val="1000"/>
+                <a:spcPts val="1400"/>
               </a:spcBef>
-              <a:defRPr sz="1250" b="1">
+              <a:defRPr sz="1800" b="1">
                 <a:solidFill>
                   <a:srgbClr val="111111"/>
                 </a:solidFill>
@@ -7092,11 +7096,11 @@
           <a:p>
             <a:pPr>
               <a:spcBef>
-                <a:spcPts val="200"/>
+                <a:spcPts val="300"/>
               </a:spcBef>
-              <a:defRPr sz="1200" b="0">
-                <a:solidFill>
-                  <a:srgbClr val="333333"/>
+              <a:defRPr sz="1650" b="0">
+                <a:solidFill>
+                  <a:srgbClr val="222222"/>
                 </a:solidFill>
                 <a:latin typeface="BIZ UDPGothic"/>
               </a:defRPr>
@@ -7120,9 +7124,9 @@
           <a:p>
             <a:pPr>
               <a:spcBef>
-                <a:spcPts val="1000"/>
+                <a:spcPts val="1400"/>
               </a:spcBef>
-              <a:defRPr sz="1250" b="1">
+              <a:defRPr sz="1800" b="1">
                 <a:solidFill>
                   <a:srgbClr val="111111"/>
                 </a:solidFill>
@@ -7136,11 +7140,11 @@
           <a:p>
             <a:pPr>
               <a:spcBef>
-                <a:spcPts val="200"/>
+                <a:spcPts val="300"/>
               </a:spcBef>
-              <a:defRPr sz="1200" b="0">
-                <a:solidFill>
-                  <a:srgbClr val="333333"/>
+              <a:defRPr sz="1650" b="0">
+                <a:solidFill>
+                  <a:srgbClr val="222222"/>
                 </a:solidFill>
                 <a:latin typeface="BIZ UDPGothic"/>
               </a:defRPr>
@@ -7171,8 +7175,8 @@
         </p:blipFill>
         <p:spPr>
           <a:xfrm>
-            <a:off x="7406640" y="731520"/>
-            <a:ext cx="4297680" cy="2286000"/>
+            <a:off x="7315200" y="731520"/>
+            <a:ext cx="4480560" cy="2377440"/>
           </a:xfrm>
           <a:prstGeom prst="rect">
             <a:avLst/>
@@ -7195,8 +7199,8 @@
         </p:blipFill>
         <p:spPr>
           <a:xfrm>
-            <a:off x="7406640" y="3108960"/>
-            <a:ext cx="4297680" cy="3017520"/>
+            <a:off x="7315200" y="3200400"/>
+            <a:ext cx="4480560" cy="3108960"/>
           </a:xfrm>
           <a:prstGeom prst="rect">
             <a:avLst/>
@@ -7230,7 +7234,7 @@
         <p:spPr>
           <a:xfrm>
             <a:off x="0" y="0"/>
-            <a:ext cx="12191695" cy="530352"/>
+            <a:ext cx="12191695" cy="585216"/>
           </a:xfrm>
           <a:prstGeom prst="rect">
             <a:avLst/>
@@ -7273,7 +7277,7 @@
         <p:spPr>
           <a:xfrm>
             <a:off x="301752" y="73152"/>
-            <a:ext cx="9144000" cy="411480"/>
+            <a:ext cx="9144000" cy="457200"/>
           </a:xfrm>
           <a:prstGeom prst="rect">
             <a:avLst/>
@@ -7287,7 +7291,7 @@
           <a:lstStyle/>
           <a:p>
             <a:pPr>
-              <a:defRPr sz="1800" b="1">
+              <a:defRPr sz="2000" b="1">
                 <a:solidFill>
                   <a:srgbClr val="FFFFFF"/>
                 </a:solidFill>
@@ -7308,8 +7312,8 @@
         </p:nvSpPr>
         <p:spPr>
           <a:xfrm>
-            <a:off x="10789920" y="128016"/>
-            <a:ext cx="484632" cy="274320"/>
+            <a:off x="10698480" y="137160"/>
+            <a:ext cx="530352" cy="301752"/>
           </a:xfrm>
           <a:prstGeom prst="roundRect">
             <a:avLst/>
@@ -7342,7 +7346,7 @@
           <a:lstStyle/>
           <a:p>
             <a:pPr algn="ctr">
-              <a:defRPr sz="1100" i="1">
+              <a:defRPr sz="1200" i="1" b="1">
                 <a:solidFill>
                   <a:srgbClr val="E8F1F8"/>
                 </a:solidFill>
@@ -7364,7 +7368,7 @@
         <p:spPr>
           <a:xfrm>
             <a:off x="11430000" y="73152"/>
-            <a:ext cx="548640" cy="411480"/>
+            <a:ext cx="548640" cy="457200"/>
           </a:xfrm>
           <a:prstGeom prst="rect">
             <a:avLst/>
@@ -7378,7 +7382,7 @@
           <a:lstStyle/>
           <a:p>
             <a:pPr algn="ctr">
-              <a:defRPr sz="1800" b="1">
+              <a:defRPr sz="2000" b="1">
                 <a:solidFill>
                   <a:srgbClr val="FFFFFF"/>
                 </a:solidFill>
@@ -7414,7 +7418,7 @@
           <a:lstStyle/>
           <a:p>
             <a:pPr algn="r">
-              <a:defRPr sz="800">
+              <a:defRPr sz="900">
                 <a:solidFill>
                   <a:srgbClr val="666666"/>
                 </a:solidFill>
@@ -7435,8 +7439,8 @@
         </p:nvSpPr>
         <p:spPr>
           <a:xfrm>
-            <a:off x="640080" y="868680"/>
-            <a:ext cx="4846320" cy="1371600"/>
+            <a:off x="548640" y="822960"/>
+            <a:ext cx="5120640" cy="1463040"/>
           </a:xfrm>
           <a:prstGeom prst="rect">
             <a:avLst/>
@@ -7453,7 +7457,7 @@
               <a:spcBef>
                 <a:spcPts val="0"/>
               </a:spcBef>
-              <a:defRPr sz="1350" b="1">
+              <a:defRPr sz="2000" b="1">
                 <a:solidFill>
                   <a:srgbClr val="111111"/>
                 </a:solidFill>
@@ -7467,11 +7471,11 @@
           <a:p>
             <a:pPr>
               <a:spcBef>
-                <a:spcPts val="400"/>
+                <a:spcPts val="600"/>
               </a:spcBef>
-              <a:defRPr sz="1200" b="0">
-                <a:solidFill>
-                  <a:srgbClr val="333333"/>
+              <a:defRPr sz="1700" b="0">
+                <a:solidFill>
+                  <a:srgbClr val="222222"/>
                 </a:solidFill>
                 <a:latin typeface="BIZ UDPGothic"/>
               </a:defRPr>
@@ -7494,8 +7498,8 @@
         </p:nvSpPr>
         <p:spPr>
           <a:xfrm>
-            <a:off x="1097280" y="2011680"/>
-            <a:ext cx="3931920" cy="1371600"/>
+            <a:off x="822960" y="2011680"/>
+            <a:ext cx="4389120" cy="1463040"/>
           </a:xfrm>
           <a:prstGeom prst="roundRect">
             <a:avLst/>
@@ -7503,7 +7507,7 @@
           <a:solidFill>
             <a:srgbClr val="EDF5FB"/>
           </a:solidFill>
-          <a:ln w="19050">
+          <a:ln w="22860">
             <a:solidFill>
               <a:srgbClr val="7BA4C7"/>
             </a:solidFill>
@@ -7528,7 +7532,7 @@
           <a:lstStyle/>
           <a:p>
             <a:pPr algn="ctr">
-              <a:defRPr sz="1300" b="1">
+              <a:defRPr sz="1700" b="1">
                 <a:solidFill>
                   <a:srgbClr val="111111"/>
                 </a:solidFill>
@@ -7544,7 +7548,7 @@
               <a:spcBef>
                 <a:spcPts val="400"/>
               </a:spcBef>
-              <a:defRPr sz="2600" b="1">
+              <a:defRPr sz="3200" b="1">
                 <a:solidFill>
                   <a:srgbClr val="00509E"/>
                 </a:solidFill>
@@ -7560,7 +7564,7 @@
               <a:spcBef>
                 <a:spcPts val="200"/>
               </a:spcBef>
-              <a:defRPr sz="1050">
+              <a:defRPr sz="1400">
                 <a:solidFill>
                   <a:srgbClr val="666666"/>
                 </a:solidFill>
@@ -7581,8 +7585,8 @@
         </p:nvSpPr>
         <p:spPr>
           <a:xfrm>
-            <a:off x="1097280" y="3749039"/>
-            <a:ext cx="3931920" cy="1371600"/>
+            <a:off x="822960" y="3749039"/>
+            <a:ext cx="4389120" cy="1463040"/>
           </a:xfrm>
           <a:prstGeom prst="roundRect">
             <a:avLst/>
@@ -7590,7 +7594,7 @@
           <a:solidFill>
             <a:srgbClr val="EDF5FB"/>
           </a:solidFill>
-          <a:ln w="19050">
+          <a:ln w="22860">
             <a:solidFill>
               <a:srgbClr val="7BA4C7"/>
             </a:solidFill>
@@ -7615,7 +7619,7 @@
           <a:lstStyle/>
           <a:p>
             <a:pPr algn="ctr">
-              <a:defRPr sz="1300" b="1">
+              <a:defRPr sz="1700" b="1">
                 <a:solidFill>
                   <a:srgbClr val="111111"/>
                 </a:solidFill>
@@ -7631,7 +7635,7 @@
               <a:spcBef>
                 <a:spcPts val="400"/>
               </a:spcBef>
-              <a:defRPr sz="2600" b="1">
+              <a:defRPr sz="3200" b="1">
                 <a:solidFill>
                   <a:srgbClr val="00509E"/>
                 </a:solidFill>
@@ -7647,7 +7651,7 @@
               <a:spcBef>
                 <a:spcPts val="200"/>
               </a:spcBef>
-              <a:defRPr sz="1050">
+              <a:defRPr sz="1400">
                 <a:solidFill>
                   <a:srgbClr val="666666"/>
                 </a:solidFill>
@@ -7676,8 +7680,8 @@
         </p:blipFill>
         <p:spPr>
           <a:xfrm>
-            <a:off x="5760720" y="731520"/>
-            <a:ext cx="6035040" cy="2651760"/>
+            <a:off x="5669280" y="731520"/>
+            <a:ext cx="6217920" cy="2743200"/>
           </a:xfrm>
           <a:prstGeom prst="rect">
             <a:avLst/>
@@ -7700,8 +7704,8 @@
         </p:blipFill>
         <p:spPr>
           <a:xfrm>
-            <a:off x="5760720" y="3474720"/>
-            <a:ext cx="6035040" cy="2926080"/>
+            <a:off x="5669280" y="3566160"/>
+            <a:ext cx="6217920" cy="2926080"/>
           </a:xfrm>
           <a:prstGeom prst="rect">
             <a:avLst/>
@@ -7735,7 +7739,7 @@
         <p:spPr>
           <a:xfrm>
             <a:off x="0" y="0"/>
-            <a:ext cx="12191695" cy="530352"/>
+            <a:ext cx="12191695" cy="585216"/>
           </a:xfrm>
           <a:prstGeom prst="rect">
             <a:avLst/>
@@ -7778,7 +7782,7 @@
         <p:spPr>
           <a:xfrm>
             <a:off x="301752" y="73152"/>
-            <a:ext cx="9144000" cy="411480"/>
+            <a:ext cx="9144000" cy="457200"/>
           </a:xfrm>
           <a:prstGeom prst="rect">
             <a:avLst/>
@@ -7792,7 +7796,7 @@
           <a:lstStyle/>
           <a:p>
             <a:pPr>
-              <a:defRPr sz="1800" b="1">
+              <a:defRPr sz="2000" b="1">
                 <a:solidFill>
                   <a:srgbClr val="FFFFFF"/>
                 </a:solidFill>
@@ -7813,8 +7817,8 @@
         </p:nvSpPr>
         <p:spPr>
           <a:xfrm>
-            <a:off x="10789920" y="128016"/>
-            <a:ext cx="484632" cy="274320"/>
+            <a:off x="10698480" y="137160"/>
+            <a:ext cx="530352" cy="301752"/>
           </a:xfrm>
           <a:prstGeom prst="roundRect">
             <a:avLst/>
@@ -7847,7 +7851,7 @@
           <a:lstStyle/>
           <a:p>
             <a:pPr algn="ctr">
-              <a:defRPr sz="1100" i="1">
+              <a:defRPr sz="1200" i="1" b="1">
                 <a:solidFill>
                   <a:srgbClr val="E8F1F8"/>
                 </a:solidFill>
@@ -7869,7 +7873,7 @@
         <p:spPr>
           <a:xfrm>
             <a:off x="11430000" y="73152"/>
-            <a:ext cx="548640" cy="411480"/>
+            <a:ext cx="548640" cy="457200"/>
           </a:xfrm>
           <a:prstGeom prst="rect">
             <a:avLst/>
@@ -7883,7 +7887,7 @@
           <a:lstStyle/>
           <a:p>
             <a:pPr algn="ctr">
-              <a:defRPr sz="1800" b="1">
+              <a:defRPr sz="2000" b="1">
                 <a:solidFill>
                   <a:srgbClr val="FFFFFF"/>
                 </a:solidFill>
@@ -7919,7 +7923,7 @@
           <a:lstStyle/>
           <a:p>
             <a:pPr algn="r">
-              <a:defRPr sz="800">
+              <a:defRPr sz="900">
                 <a:solidFill>
                   <a:srgbClr val="666666"/>
                 </a:solidFill>
@@ -7948,8 +7952,8 @@
         </p:blipFill>
         <p:spPr>
           <a:xfrm>
-            <a:off x="2103120" y="731520"/>
-            <a:ext cx="7863840" cy="5394960"/>
+            <a:off x="2194560" y="731520"/>
+            <a:ext cx="7772400" cy="5394960"/>
           </a:xfrm>
           <a:prstGeom prst="rect">
             <a:avLst/>
@@ -7964,8 +7968,8 @@
         </p:nvSpPr>
         <p:spPr>
           <a:xfrm>
-            <a:off x="320040" y="1280160"/>
-            <a:ext cx="1554480" cy="502920"/>
+            <a:off x="228600" y="1280160"/>
+            <a:ext cx="1828800" cy="548640"/>
           </a:xfrm>
           <a:prstGeom prst="roundRect">
             <a:avLst/>
@@ -7973,7 +7977,7 @@
           <a:solidFill>
             <a:srgbClr val="FFFFFF"/>
           </a:solidFill>
-          <a:ln w="15240">
+          <a:ln w="19050">
             <a:solidFill>
               <a:srgbClr val="7BA4C7"/>
             </a:solidFill>
@@ -7998,7 +8002,7 @@
           <a:lstStyle/>
           <a:p>
             <a:pPr algn="ctr">
-              <a:defRPr sz="1100">
+              <a:defRPr sz="1500" b="1">
                 <a:solidFill>
                   <a:srgbClr val="111111"/>
                 </a:solidFill>
@@ -8019,8 +8023,8 @@
         </p:nvSpPr>
         <p:spPr>
           <a:xfrm>
-            <a:off x="320040" y="2103120"/>
-            <a:ext cx="1554480" cy="502920"/>
+            <a:off x="228600" y="2057400"/>
+            <a:ext cx="1828800" cy="548640"/>
           </a:xfrm>
           <a:prstGeom prst="roundRect">
             <a:avLst/>
@@ -8028,7 +8032,7 @@
           <a:solidFill>
             <a:srgbClr val="FFFFFF"/>
           </a:solidFill>
-          <a:ln w="15240">
+          <a:ln w="19050">
             <a:solidFill>
               <a:srgbClr val="7BA4C7"/>
             </a:solidFill>
@@ -8053,7 +8057,7 @@
           <a:lstStyle/>
           <a:p>
             <a:pPr algn="ctr">
-              <a:defRPr sz="1100">
+              <a:defRPr sz="1500" b="1">
                 <a:solidFill>
                   <a:srgbClr val="111111"/>
                 </a:solidFill>
@@ -8074,8 +8078,8 @@
         </p:nvSpPr>
         <p:spPr>
           <a:xfrm>
-            <a:off x="320040" y="2834640"/>
-            <a:ext cx="1554480" cy="502920"/>
+            <a:off x="228600" y="2834640"/>
+            <a:ext cx="1828800" cy="548640"/>
           </a:xfrm>
           <a:prstGeom prst="roundRect">
             <a:avLst/>
@@ -8083,7 +8087,7 @@
           <a:solidFill>
             <a:srgbClr val="FFFFFF"/>
           </a:solidFill>
-          <a:ln w="15240">
+          <a:ln w="19050">
             <a:solidFill>
               <a:srgbClr val="7BA4C7"/>
             </a:solidFill>
@@ -8108,7 +8112,7 @@
           <a:lstStyle/>
           <a:p>
             <a:pPr algn="ctr">
-              <a:defRPr sz="1100">
+              <a:defRPr sz="1500" b="1">
                 <a:solidFill>
                   <a:srgbClr val="111111"/>
                 </a:solidFill>
@@ -8129,8 +8133,8 @@
         </p:nvSpPr>
         <p:spPr>
           <a:xfrm>
-            <a:off x="320040" y="3657600"/>
-            <a:ext cx="1554480" cy="502920"/>
+            <a:off x="228600" y="3611880"/>
+            <a:ext cx="1828800" cy="548640"/>
           </a:xfrm>
           <a:prstGeom prst="roundRect">
             <a:avLst/>
@@ -8138,7 +8142,7 @@
           <a:solidFill>
             <a:srgbClr val="FFFFFF"/>
           </a:solidFill>
-          <a:ln w="15240">
+          <a:ln w="19050">
             <a:solidFill>
               <a:srgbClr val="7BA4C7"/>
             </a:solidFill>
@@ -8163,7 +8167,7 @@
           <a:lstStyle/>
           <a:p>
             <a:pPr algn="ctr">
-              <a:defRPr sz="1100">
+              <a:defRPr sz="1500" b="1">
                 <a:solidFill>
                   <a:srgbClr val="111111"/>
                 </a:solidFill>
@@ -8184,8 +8188,8 @@
         </p:nvSpPr>
         <p:spPr>
           <a:xfrm>
-            <a:off x="914400" y="5120640"/>
-            <a:ext cx="2103120" cy="731520"/>
+            <a:off x="822960" y="5120640"/>
+            <a:ext cx="2377440" cy="777240"/>
           </a:xfrm>
           <a:prstGeom prst="roundRect">
             <a:avLst/>
@@ -8193,7 +8197,7 @@
           <a:solidFill>
             <a:srgbClr val="FFFFFF"/>
           </a:solidFill>
-          <a:ln w="15240">
+          <a:ln w="19050">
             <a:solidFill>
               <a:srgbClr val="7BA4C7"/>
             </a:solidFill>
@@ -8218,7 +8222,7 @@
           <a:lstStyle/>
           <a:p>
             <a:pPr algn="ctr">
-              <a:defRPr sz="1100">
+              <a:defRPr sz="1500" b="1">
                 <a:solidFill>
                   <a:srgbClr val="111111"/>
                 </a:solidFill>
@@ -8261,7 +8265,7 @@
               <a:spcBef>
                 <a:spcPts val="0"/>
               </a:spcBef>
-              <a:defRPr sz="1250" b="1">
+              <a:defRPr sz="1600" b="1">
                 <a:solidFill>
                   <a:srgbClr val="111111"/>
                 </a:solidFill>
@@ -8275,9 +8279,9 @@
           <a:p>
             <a:pPr>
               <a:spcBef>
-                <a:spcPts val="3000"/>
+                <a:spcPts val="2600"/>
               </a:spcBef>
-              <a:defRPr sz="1250" b="1">
+              <a:defRPr sz="1600" b="1">
                 <a:solidFill>
                   <a:srgbClr val="111111"/>
                 </a:solidFill>
@@ -8295,9 +8299,9 @@
           <a:p>
             <a:pPr>
               <a:spcBef>
-                <a:spcPts val="4000"/>
+                <a:spcPts val="3600"/>
               </a:spcBef>
-              <a:defRPr sz="1150" b="1">
+              <a:defRPr sz="1400" b="1">
                 <a:solidFill>
                   <a:srgbClr val="0B3968"/>
                 </a:solidFill>

</xml_diff>

<commit_message>
content(hvac): publish v2 slide deck and refresh code bundle
限定共有ページのスライドを、現場発表版のブラッシュアップ（v2）へ
差し替える。あわせてコードバンドルを panasonic-ew の 00b61d6 で更新。

主な変更点

- P05・P06 のタイトルを中身に合わせる（前提と制約 / 構築と工夫）
- P08 に、画面の数値がダミーデータによる表示例である旨の脚注を追加
- P09 の課題を5点へ具体化、展望に根拠を一言ずつ追加
- P10 に「技術面で学んだこと」を新設
- 「クレーム」という表現を全体で言い換え

Co-Authored-By: Claude Sonnet 5 <noreply@anthropic.com>
</commit_message>
<xml_diff>
--- a/public/slides/hvac-precooling-slides.pptx
+++ b/public/slides/hvac-precooling-slides.pptx
@@ -3642,7 +3642,7 @@
               <a:spcBef>
                 <a:spcPts val="0"/>
               </a:spcBef>
-              <a:defRPr sz="2000" b="1">
+              <a:defRPr sz="1900" b="1">
                 <a:solidFill>
                   <a:srgbClr val="111111"/>
                 </a:solidFill>
@@ -3651,6 +3651,38 @@
             </a:pPr>
             <a:r>
               <a:t>■ 課題</a:t>
+            </a:r>
+          </a:p>
+          <a:p>
+            <a:pPr>
+              <a:spcBef>
+                <a:spcPts val="600"/>
+              </a:spcBef>
+              <a:defRPr sz="1650" b="1">
+                <a:solidFill>
+                  <a:srgbClr val="111111"/>
+                </a:solidFill>
+                <a:latin typeface="BIZ UDPGothic"/>
+              </a:defRPr>
+            </a:pPr>
+            <a:r>
+              <a:t>1. 休み明けの補正が1件からの逆算である</a:t>
+            </a:r>
+          </a:p>
+          <a:p>
+            <a:pPr>
+              <a:spcBef>
+                <a:spcPts val="200"/>
+              </a:spcBef>
+              <a:defRPr sz="1500" b="0">
+                <a:solidFill>
+                  <a:srgbClr val="222222"/>
+                </a:solidFill>
+                <a:latin typeface="BIZ UDPGothic"/>
+              </a:defRPr>
+            </a:pPr>
+            <a:r>
+              <a:t>・+2.0℃ は休日明け n=1 から逆算した暫定値で、同じデータでは検証できない</a:t>
             </a:r>
           </a:p>
           <a:p>
@@ -3658,7 +3690,7 @@
               <a:spcBef>
                 <a:spcPts val="800"/>
               </a:spcBef>
-              <a:defRPr sz="1800" b="1">
+              <a:defRPr sz="1650" b="1">
                 <a:solidFill>
                   <a:srgbClr val="111111"/>
                 </a:solidFill>
@@ -3666,7 +3698,151 @@
               </a:defRPr>
             </a:pPr>
             <a:r>
-              <a:t>1. 休み明けの予測の正確性</a:t>
+              <a:t>2. 目的変数そのものに分解能の限界がある</a:t>
+            </a:r>
+          </a:p>
+          <a:p>
+            <a:pPr>
+              <a:spcBef>
+                <a:spcPts val="200"/>
+              </a:spcBef>
+              <a:defRPr sz="1500" b="0">
+                <a:solidFill>
+                  <a:srgbClr val="222222"/>
+                </a:solidFill>
+                <a:latin typeface="BIZ UDPGothic"/>
+              </a:defRPr>
+            </a:pPr>
+            <a:r>
+              <a:t>・室温ログが0.5℃刻みのため到達時刻の特定に幅が出る。平均誤差3.7分と同オーダー</a:t>
+            </a:r>
+          </a:p>
+          <a:p>
+            <a:pPr>
+              <a:spcBef>
+                <a:spcPts val="800"/>
+              </a:spcBef>
+              <a:defRPr sz="1650" b="1">
+                <a:solidFill>
+                  <a:srgbClr val="111111"/>
+                </a:solidFill>
+                <a:latin typeface="BIZ UDPGothic"/>
+              </a:defRPr>
+            </a:pPr>
+            <a:r>
+              <a:t>3. 外気温の観測範囲が狭い</a:t>
+            </a:r>
+          </a:p>
+          <a:p>
+            <a:pPr>
+              <a:spcBef>
+                <a:spcPts val="200"/>
+              </a:spcBef>
+              <a:defRPr sz="1500" b="0">
+                <a:solidFill>
+                  <a:srgbClr val="222222"/>
+                </a:solidFill>
+                <a:latin typeface="BIZ UDPGothic"/>
+              </a:defRPr>
+            </a:pPr>
+            <a:r>
+              <a:t>・2週間・8月下旬のため学習範囲は約28℃前後に集中。猛暑日や涼しい朝は外挿になる</a:t>
+            </a:r>
+          </a:p>
+          <a:p>
+            <a:pPr>
+              <a:spcBef>
+                <a:spcPts val="800"/>
+              </a:spcBef>
+              <a:defRPr sz="1650" b="1">
+                <a:solidFill>
+                  <a:srgbClr val="111111"/>
+                </a:solidFill>
+                <a:latin typeface="BIZ UDPGothic"/>
+              </a:defRPr>
+            </a:pPr>
+            <a:r>
+              <a:t>4. 未達をどこまで許容するかは技術では決められない</a:t>
+            </a:r>
+          </a:p>
+          <a:p>
+            <a:pPr>
+              <a:spcBef>
+                <a:spcPts val="200"/>
+              </a:spcBef>
+              <a:defRPr sz="1500" b="0">
+                <a:solidFill>
+                  <a:srgbClr val="222222"/>
+                </a:solidFill>
+                <a:latin typeface="BIZ UDPGothic"/>
+              </a:defRPr>
+            </a:pPr>
+            <a:r>
+              <a:t>・安全側の分位をどこに置くかは現場が許容できる未達リスク次第。運用値は要合意</a:t>
+            </a:r>
+          </a:p>
+          <a:p>
+            <a:pPr>
+              <a:spcBef>
+                <a:spcPts val="800"/>
+              </a:spcBef>
+              <a:defRPr sz="1650" b="1">
+                <a:solidFill>
+                  <a:srgbClr val="111111"/>
+                </a:solidFill>
+                <a:latin typeface="BIZ UDPGothic"/>
+              </a:defRPr>
+            </a:pPr>
+            <a:r>
+              <a:t>5. 検証が同一期間のバックテストである</a:t>
+            </a:r>
+          </a:p>
+          <a:p>
+            <a:pPr>
+              <a:spcBef>
+                <a:spcPts val="200"/>
+              </a:spcBef>
+              <a:defRPr sz="1500" b="0">
+                <a:solidFill>
+                  <a:srgbClr val="222222"/>
+                </a:solidFill>
+                <a:latin typeface="BIZ UDPGothic"/>
+              </a:defRPr>
+            </a:pPr>
+            <a:r>
+              <a:t>・到達率100%は学習に使った2週間への後ろ向き検証。前向き運用での実証は今後</a:t>
+            </a:r>
+          </a:p>
+          <a:p>
+            <a:pPr>
+              <a:spcBef>
+                <a:spcPts val="1600"/>
+              </a:spcBef>
+              <a:defRPr sz="1900" b="1">
+                <a:solidFill>
+                  <a:srgbClr val="111111"/>
+                </a:solidFill>
+                <a:latin typeface="BIZ UDPGothic"/>
+              </a:defRPr>
+            </a:pPr>
+            <a:r>
+              <a:t>■ 今後の展望</a:t>
+            </a:r>
+          </a:p>
+          <a:p>
+            <a:pPr>
+              <a:spcBef>
+                <a:spcPts val="600"/>
+              </a:spcBef>
+              <a:defRPr sz="1550" b="0">
+                <a:solidFill>
+                  <a:srgbClr val="222222"/>
+                </a:solidFill>
+                <a:latin typeface="BIZ UDPGothic"/>
+              </a:defRPr>
+            </a:pPr>
+            <a:r>
+              <a:t>1. 暖房期への対応 － 未達が高コストという損失の向きは同じ。係数を取り直せば枠組みは流用できる</a:t>
             </a:r>
           </a:p>
           <a:p>
@@ -3674,7 +3850,7 @@
               <a:spcBef>
                 <a:spcPts val="400"/>
               </a:spcBef>
-              <a:defRPr sz="1700" b="0">
+              <a:defRPr sz="1550" b="0">
                 <a:solidFill>
                   <a:srgbClr val="222222"/>
                 </a:solidFill>
@@ -3682,23 +3858,7 @@
               </a:defRPr>
             </a:pPr>
             <a:r>
-              <a:t>・現状は平日運用とほぼ同じモデルを利用しているため、モデルとして適していない可能性</a:t>
-            </a:r>
-          </a:p>
-          <a:p>
-            <a:pPr>
-              <a:spcBef>
-                <a:spcPts val="1400"/>
-              </a:spcBef>
-              <a:defRPr sz="1800" b="1">
-                <a:solidFill>
-                  <a:srgbClr val="111111"/>
-                </a:solidFill>
-                <a:latin typeface="BIZ UDPGothic"/>
-              </a:defRPr>
-            </a:pPr>
-            <a:r>
-              <a:t>2. データ期間が短い</a:t>
+              <a:t>2. 他フロア・他棟への展開 － 躯体の熱容量が異なるため、係数はフロアごとに学習する必要がある</a:t>
             </a:r>
           </a:p>
           <a:p>
@@ -3706,7 +3866,7 @@
               <a:spcBef>
                 <a:spcPts val="400"/>
               </a:spcBef>
-              <a:defRPr sz="1700" b="0">
+              <a:defRPr sz="1550" b="0">
                 <a:solidFill>
                   <a:srgbClr val="222222"/>
                 </a:solidFill>
@@ -3714,87 +3874,23 @@
               </a:defRPr>
             </a:pPr>
             <a:r>
-              <a:t>・詳細なデータは2週間分であったため、より一般的な傾向をとらえきれていない可能性がある</a:t>
+              <a:t>3. 追加変数の検討 － 外気湿度は精度向上がわずかで今回は見送り。データが増えれば再評価の余地</a:t>
             </a:r>
           </a:p>
           <a:p>
             <a:pPr>
               <a:spcBef>
-                <a:spcPts val="2600"/>
+                <a:spcPts val="400"/>
               </a:spcBef>
-              <a:defRPr sz="2000" b="1">
-                <a:solidFill>
-                  <a:srgbClr val="111111"/>
-                </a:solidFill>
-                <a:latin typeface="BIZ UDPGothic"/>
-              </a:defRPr>
-            </a:pPr>
-            <a:r>
-              <a:t>■ 今後の展望</a:t>
-            </a:r>
-          </a:p>
-          <a:p>
-            <a:pPr>
-              <a:spcBef>
-                <a:spcPts val="800"/>
-              </a:spcBef>
-              <a:defRPr sz="1800" b="1">
-                <a:solidFill>
-                  <a:srgbClr val="111111"/>
-                </a:solidFill>
-                <a:latin typeface="BIZ UDPGothic"/>
-              </a:defRPr>
-            </a:pPr>
-            <a:r>
-              <a:t>1. 暖房期への対応</a:t>
-            </a:r>
-          </a:p>
-          <a:p>
-            <a:pPr>
-              <a:spcBef>
-                <a:spcPts val="800"/>
-              </a:spcBef>
-              <a:defRPr sz="1800" b="1">
-                <a:solidFill>
-                  <a:srgbClr val="111111"/>
-                </a:solidFill>
-                <a:latin typeface="BIZ UDPGothic"/>
-              </a:defRPr>
-            </a:pPr>
-            <a:r>
-              <a:t>2. 第二別館内の他フロア、または他棟への展開</a:t>
-            </a:r>
-          </a:p>
-          <a:p>
-            <a:pPr>
-              <a:spcBef>
-                <a:spcPts val="800"/>
-              </a:spcBef>
-              <a:defRPr sz="1800" b="1">
-                <a:solidFill>
-                  <a:srgbClr val="111111"/>
-                </a:solidFill>
-                <a:latin typeface="BIZ UDPGothic"/>
-              </a:defRPr>
-            </a:pPr>
-            <a:r>
-              <a:t>3. 外気温度、設定温度以外の変数の考慮（外気湿度など）</a:t>
-            </a:r>
-          </a:p>
-          <a:p>
-            <a:pPr>
-              <a:spcBef>
-                <a:spcPts val="800"/>
-              </a:spcBef>
-              <a:defRPr sz="1800" b="1">
-                <a:solidFill>
-                  <a:srgbClr val="111111"/>
-                </a:solidFill>
-                <a:latin typeface="BIZ UDPGothic"/>
-              </a:defRPr>
-            </a:pPr>
-            <a:r>
-              <a:t>4. データ読み取り → モデル再学習</a:t>
+              <a:defRPr sz="1550" b="0">
+                <a:solidFill>
+                  <a:srgbClr val="222222"/>
+                </a:solidFill>
+                <a:latin typeface="BIZ UDPGothic"/>
+              </a:defRPr>
+            </a:pPr>
+            <a:r>
+              <a:t>4. 再学習サイクル － 係数はJSON経由で画面へ渡す構造。データを足して学習し直せば画面が追随する</a:t>
             </a:r>
           </a:p>
         </p:txBody>
@@ -4049,7 +4145,7 @@
               <a:spcBef>
                 <a:spcPts val="0"/>
               </a:spcBef>
-              <a:defRPr sz="2000" b="1">
+              <a:defRPr sz="1900" b="1">
                 <a:solidFill>
                   <a:srgbClr val="111111"/>
                 </a:solidFill>
@@ -4057,15 +4153,15 @@
               </a:defRPr>
             </a:pPr>
             <a:r>
-              <a:t>■ 実習を通して</a:t>
+              <a:t>■ 技術面で学んだこと</a:t>
             </a:r>
           </a:p>
           <a:p>
             <a:pPr>
               <a:spcBef>
-                <a:spcPts val="800"/>
+                <a:spcPts val="600"/>
               </a:spcBef>
-              <a:defRPr sz="1750" b="0">
+              <a:defRPr sz="1650" b="0">
                 <a:solidFill>
                   <a:srgbClr val="222222"/>
                 </a:solidFill>
@@ -4073,19 +4169,51 @@
               </a:defRPr>
             </a:pPr>
             <a:r>
-              <a:t>・お客様目線でのアプリケーション開発は相手の要望を想像しながらしなければいけない部分もあり、</a:t>
+              <a:t>・予測精度より先に、いつ・誰が・何を知った状態で決めるかを捉える必要がある</a:t>
             </a:r>
             <a:br/>
             <a:r>
-              <a:t>  難しかった。</a:t>
+              <a:t>　→ 前日夕方に決めるという制約が、室温を使わないモデル設計そのものを決めた</a:t>
             </a:r>
           </a:p>
           <a:p>
             <a:pPr>
               <a:spcBef>
-                <a:spcPts val="3000"/>
+                <a:spcPts val="400"/>
               </a:spcBef>
-              <a:defRPr sz="2000" b="1">
+              <a:defRPr sz="1650" b="0">
+                <a:solidFill>
+                  <a:srgbClr val="222222"/>
+                </a:solidFill>
+                <a:latin typeface="BIZ UDPGothic"/>
+              </a:defRPr>
+            </a:pPr>
+            <a:r>
+              <a:t>・未達と過剰予冷では損失の大きさが違い、平均誤差だけでは運用の判断基準を設計できない</a:t>
+            </a:r>
+          </a:p>
+          <a:p>
+            <a:pPr>
+              <a:spcBef>
+                <a:spcPts val="400"/>
+              </a:spcBef>
+              <a:defRPr sz="1650" b="0">
+                <a:solidFill>
+                  <a:srgbClr val="222222"/>
+                </a:solidFill>
+                <a:latin typeface="BIZ UDPGothic"/>
+              </a:defRPr>
+            </a:pPr>
+            <a:r>
+              <a:t>・当てはまりの良さより、係数の符号が物理的に妥当かを見る必要がある</a:t>
+            </a:r>
+          </a:p>
+          <a:p>
+            <a:pPr>
+              <a:spcBef>
+                <a:spcPts val="1800"/>
+              </a:spcBef>
+              <a:defRPr sz="1900" b="1">
                 <a:solidFill>
                   <a:srgbClr val="111111"/>
                 </a:solidFill>
@@ -4093,15 +4221,79 @@
               </a:defRPr>
             </a:pPr>
             <a:r>
+              <a:t>■ お客様目線での開発</a:t>
+            </a:r>
+          </a:p>
+          <a:p>
+            <a:pPr>
+              <a:spcBef>
+                <a:spcPts val="600"/>
+              </a:spcBef>
+              <a:defRPr sz="1650" b="0">
+                <a:solidFill>
+                  <a:srgbClr val="222222"/>
+                </a:solidFill>
+                <a:latin typeface="BIZ UDPGothic"/>
+              </a:defRPr>
+            </a:pPr>
+            <a:r>
+              <a:t>・BMが最も避けたいのは始業時の未達であり、朝は起動をやり直すことができない</a:t>
+            </a:r>
+          </a:p>
+          <a:p>
+            <a:pPr>
+              <a:spcBef>
+                <a:spcPts val="400"/>
+              </a:spcBef>
+              <a:defRPr sz="1650" b="0">
+                <a:solidFill>
+                  <a:srgbClr val="222222"/>
+                </a:solidFill>
+                <a:latin typeface="BIZ UDPGothic"/>
+              </a:defRPr>
+            </a:pPr>
+            <a:r>
+              <a:t>・だから推奨値だけでなく、根拠と適用限界（外挿警告・予冷時間の内訳）を画面に出す設計にした</a:t>
+            </a:r>
+          </a:p>
+          <a:p>
+            <a:pPr>
+              <a:spcBef>
+                <a:spcPts val="400"/>
+              </a:spcBef>
+              <a:defRPr sz="1650" b="0">
+                <a:solidFill>
+                  <a:srgbClr val="222222"/>
+                </a:solidFill>
+                <a:latin typeface="BIZ UDPGothic"/>
+              </a:defRPr>
+            </a:pPr>
+            <a:r>
+              <a:t>・相手の運用と立場を想像しながら作る難しさと重要性を学んだ</a:t>
+            </a:r>
+          </a:p>
+          <a:p>
+            <a:pPr>
+              <a:spcBef>
+                <a:spcPts val="1800"/>
+              </a:spcBef>
+              <a:defRPr sz="1900" b="1">
+                <a:solidFill>
+                  <a:srgbClr val="111111"/>
+                </a:solidFill>
+                <a:latin typeface="BIZ UDPGothic"/>
+              </a:defRPr>
+            </a:pPr>
+            <a:r>
               <a:t>■ インターンシップを通して</a:t>
             </a:r>
           </a:p>
           <a:p>
             <a:pPr>
               <a:spcBef>
-                <a:spcPts val="800"/>
+                <a:spcPts val="600"/>
               </a:spcBef>
-              <a:defRPr sz="1750" b="0">
+              <a:defRPr sz="1650" b="0">
                 <a:solidFill>
                   <a:srgbClr val="222222"/>
                 </a:solidFill>
@@ -4113,7 +4305,7 @@
             </a:r>
             <a:br/>
             <a:r>
-              <a:t>  様々なものに触れられて、とても実りある2週間でした</a:t>
+              <a:t>　様々なものに触れられて、とても実りある2週間でした</a:t>
             </a:r>
           </a:p>
         </p:txBody>
@@ -6100,15 +6292,15 @@
             </a:r>
             <a:br/>
             <a:r>
-              <a:t>・8:00 の始業時に冷え切っていないとクレーム</a:t>
+              <a:t>・始業時の未達は執務環境に直結し、朝は</a:t>
             </a:r>
             <a:br/>
             <a:r>
-              <a:t>  になる</a:t>
+              <a:t>  やり直しがきかない</a:t>
             </a:r>
             <a:br/>
             <a:r>
-              <a:t>  →かなり余裕のある起動時間設定</a:t>
+              <a:t>  →確実性を優先した起動設定</a:t>
             </a:r>
           </a:p>
         </p:txBody>
@@ -6304,7 +6496,7 @@
               </a:defRPr>
             </a:pPr>
             <a:r>
-              <a:t>5. モデルの開発</a:t>
+              <a:t>5. モデル設計の前提と制約</a:t>
             </a:r>
           </a:p>
         </p:txBody>
@@ -6538,7 +6730,7 @@
               </a:defRPr>
             </a:pPr>
             <a:r>
-              <a:t>・始業時に設定温度未達 → 快適性を損なう(高コスト)</a:t>
+              <a:t>・始業時に設定温度未達 → 執務環境に直結し、朝はやり直しがきかない(高コスト)</a:t>
             </a:r>
             <a:br/>
             <a:r>
@@ -6868,7 +7060,7 @@
               </a:defRPr>
             </a:pPr>
             <a:r>
-              <a:t>6. アプリ開発</a:t>
+              <a:t>6. モデルの構築と工夫</a:t>
             </a:r>
           </a:p>
         </p:txBody>
@@ -7119,6 +7311,22 @@
             <a:br/>
             <a:r>
               <a:t>・データが少ないため、予想外気温に+2.0℃ することで対応</a:t>
+            </a:r>
+          </a:p>
+          <a:p>
+            <a:pPr>
+              <a:spcBef>
+                <a:spcPts val="200"/>
+              </a:spcBef>
+              <a:defRPr sz="1400" b="0">
+                <a:solidFill>
+                  <a:srgbClr val="444444"/>
+                </a:solidFill>
+                <a:latin typeface="BIZ UDPGothic"/>
+              </a:defRPr>
+            </a:pPr>
+            <a:r>
+              <a:t>※ +2.0℃ は n=1 から逆算した暫定値。運用前に実データでの再確認が必要</a:t>
             </a:r>
           </a:p>
           <a:p>
@@ -8314,6 +8522,42 @@
             <a:br/>
             <a:r>
               <a:t>青、赤: 設定温度到達時刻</a:t>
+            </a:r>
+          </a:p>
+        </p:txBody>
+      </p:sp>
+      <p:sp>
+        <p:nvSpPr>
+          <p:cNvPr id="14" name="TextBox 13"/>
+          <p:cNvSpPr txBox="1"/>
+          <p:nvPr/>
+        </p:nvSpPr>
+        <p:spPr>
+          <a:xfrm>
+            <a:off x="301752" y="6263640"/>
+            <a:ext cx="10058400" cy="365760"/>
+          </a:xfrm>
+          <a:prstGeom prst="rect">
+            <a:avLst/>
+          </a:prstGeom>
+          <a:noFill/>
+        </p:spPr>
+        <p:txBody>
+          <a:bodyPr wrap="none">
+            <a:spAutoFit/>
+          </a:bodyPr>
+          <a:lstStyle/>
+          <a:p>
+            <a:pPr>
+              <a:defRPr sz="1300" b="1">
+                <a:solidFill>
+                  <a:srgbClr val="C8102E"/>
+                </a:solidFill>
+                <a:latin typeface="BIZ UDPGothic"/>
+              </a:defRPr>
+            </a:pPr>
+            <a:r>
+              <a:t>※ 画面の数値はダミーデータによる表示例であり、実測値ではない（実データでの検証結果は P7）</a:t>
             </a:r>
           </a:p>
         </p:txBody>

</xml_diff>

<commit_message>
content(hvac): polish v2 deck wording
panasonic-ew 側で v2 スライドの日本語を整えたものを反映する。
ダミーデータ由来の数値（外気温の学習範囲）を本文から外した。

Co-Authored-By: Claude Fable 5.1 <noreply@anthropic.com>
</commit_message>
<xml_diff>
--- a/public/slides/hvac-precooling-slides.pptx
+++ b/public/slides/hvac-precooling-slides.pptx
@@ -3666,7 +3666,7 @@
               </a:defRPr>
             </a:pPr>
             <a:r>
-              <a:t>1. 休み明けの補正が1件からの逆算である</a:t>
+              <a:t>1. 休み明けの補正は1件からの逆算</a:t>
             </a:r>
           </a:p>
           <a:p>
@@ -3682,7 +3682,7 @@
               </a:defRPr>
             </a:pPr>
             <a:r>
-              <a:t>・+2.0℃ は休日明け n=1 から逆算した暫定値で、同じデータでは検証できない</a:t>
+              <a:t>・+2.0℃ は休日明け1件（n=1）から逆算した暫定値で、同じデータでは検証できない</a:t>
             </a:r>
           </a:p>
           <a:p>
@@ -3698,7 +3698,7 @@
               </a:defRPr>
             </a:pPr>
             <a:r>
-              <a:t>2. 目的変数そのものに分解能の限界がある</a:t>
+              <a:t>2. 目的変数の分解能に限界がある</a:t>
             </a:r>
           </a:p>
           <a:p>
@@ -3714,7 +3714,7 @@
               </a:defRPr>
             </a:pPr>
             <a:r>
-              <a:t>・室温ログが0.5℃刻みのため到達時刻の特定に幅が出る。平均誤差3.7分と同オーダー</a:t>
+              <a:t>・室温ログが0.5℃刻みのため、到達時刻の特定に幅が出る。平均誤差3.7分と同程度の大きさ</a:t>
             </a:r>
           </a:p>
           <a:p>
@@ -3746,7 +3746,7 @@
               </a:defRPr>
             </a:pPr>
             <a:r>
-              <a:t>・2週間・8月下旬のため学習範囲は約28℃前後に集中。猛暑日や涼しい朝は外挿になる</a:t>
+              <a:t>・8月下旬の2週間分のため、学習範囲が早朝の狭い気温帯に集中。猛暑日や涼しい朝は外挿になる</a:t>
             </a:r>
           </a:p>
           <a:p>
@@ -3762,7 +3762,7 @@
               </a:defRPr>
             </a:pPr>
             <a:r>
-              <a:t>4. 未達をどこまで許容するかは技術では決められない</a:t>
+              <a:t>4. 未達の許容度は技術では決められない</a:t>
             </a:r>
           </a:p>
           <a:p>
@@ -3778,7 +3778,7 @@
               </a:defRPr>
             </a:pPr>
             <a:r>
-              <a:t>・安全側の分位をどこに置くかは現場が許容できる未達リスク次第。運用値は要合意</a:t>
+              <a:t>・安全側の分位をどこに置くかは、現場が許容できる未達リスク次第。運用値は現場と合意して決める</a:t>
             </a:r>
           </a:p>
           <a:p>
@@ -3794,7 +3794,7 @@
               </a:defRPr>
             </a:pPr>
             <a:r>
-              <a:t>5. 検証が同一期間のバックテストである</a:t>
+              <a:t>5. 検証は同一期間のバックテスト</a:t>
             </a:r>
           </a:p>
           <a:p>
@@ -3810,7 +3810,7 @@
               </a:defRPr>
             </a:pPr>
             <a:r>
-              <a:t>・到達率100%は学習に使った2週間への後ろ向き検証。前向き運用での実証は今後</a:t>
+              <a:t>・到達率100%は、学習に使った2週間に対する後ろ向きの検証。前向き運用での実証はこれから</a:t>
             </a:r>
           </a:p>
           <a:p>
@@ -3858,7 +3858,7 @@
               </a:defRPr>
             </a:pPr>
             <a:r>
-              <a:t>2. 他フロア・他棟への展開 － 躯体の熱容量が異なるため、係数はフロアごとに学習する必要がある</a:t>
+              <a:t>2. 他フロア・他棟への展開 － 躯体の熱容量が異なるため、係数はフロアごとに学習し直す</a:t>
             </a:r>
           </a:p>
           <a:p>
@@ -3874,7 +3874,7 @@
               </a:defRPr>
             </a:pPr>
             <a:r>
-              <a:t>3. 追加変数の検討 － 外気湿度は精度向上がわずかで今回は見送り。データが増えれば再評価の余地</a:t>
+              <a:t>3. 追加変数の検討 － 外気湿度は精度向上がわずかで今回は見送った。データが増えれば再評価の余地がある</a:t>
             </a:r>
           </a:p>
           <a:p>
@@ -3890,7 +3890,7 @@
               </a:defRPr>
             </a:pPr>
             <a:r>
-              <a:t>4. 再学習サイクル － 係数はJSON経由で画面へ渡す構造。データを足して学習し直せば画面が追随する</a:t>
+              <a:t>4. 再学習サイクル － 係数はファイル経由で画面へ渡す構造。学習し直せば画面が自動で追随する</a:t>
             </a:r>
           </a:p>
         </p:txBody>
@@ -4253,7 +4253,7 @@
               </a:defRPr>
             </a:pPr>
             <a:r>
-              <a:t>・だから推奨値だけでなく、根拠と適用限界（外挿警告・予冷時間の内訳）を画面に出す設計にした</a:t>
+              <a:t>・そのため推奨値だけでなく、根拠と適用限界（外挿警告・予冷時間の内訳）を画面に出す設計にした</a:t>
             </a:r>
           </a:p>
           <a:p>
@@ -6730,7 +6730,7 @@
               </a:defRPr>
             </a:pPr>
             <a:r>
-              <a:t>・始業時に設定温度未達 → 執務環境に直結し、朝はやり直しがきかない(高コスト)</a:t>
+              <a:t>・始業時に設定温度未達 → 執務環境に直接影響し、起動のやり直しがきかない(高コスト)</a:t>
             </a:r>
             <a:br/>
             <a:r>

</xml_diff>

<commit_message>
content(hvac): update slide 7 with app-centric issues and outlook mapping
</commit_message>
<xml_diff>
--- a/public/slides/hvac-precooling-slides.pptx
+++ b/public/slides/hvac-precooling-slides.pptx
@@ -1000,7 +1000,7 @@
           <a:lstStyle/>
           <a:p>
             <a:r>
-              <a:t>結論、今回明らかになった課題と今後の展望です。本実習を通じ、過去データから予冷時間を推計し、起動時刻決定と削減電力量の推定を行う仕組みを確立し、BM向けの可視化アプリを完成させることができました。一方で、休み明けの標本数が少ない点や、室温データの分解能に伴うモデル精度の向上、そして暖房期への対応が今後の課題です。今後は、日々の実運用データを自動で取り込んでモデルを再学習するサイクルの構築や、冬季データを用いた暖房予測モデルの構築へと展開していく予定です。</a:t>
+              <a:t>結論として、本実習のまとめと、今回明らかになった課題および今後の展望です。まずまとめとして、翌朝の気象予報から予冷時間を推計し、推奨起動時刻と削減電力量を提示するBM向けの運用支援アプリを構築いたしました。単に推奨時刻を押し付けるのではなく、安全余裕の内訳やトレードオフ曲線を透明に提示することで、現場の担当者が納得と安心感を持って起動を遅らせられるUI設計を確立できました。一方で、本アプリを現場で本格運用していく上での課題と、それに対応する今後の展望が3点あります。1点目は、実績振り返り機能の不足です。前日に決めた後、翌朝実際に何時に到達しどれだけ電力を削減できたかを検証する画面がありません。今後は省エネ実績ダッシュボードを実装し、翌朝の実績を自動可視化することで、運用の安心感と信頼性を高めていきます。2点目は、モデルの陳腐化リスクです。運用データが溜まっても自動再学習する仕組みがなく、季節の推移や設備変化に追従できません。今後は日々のBEMSデータを取り込んで定期的に自動再学習するサイクルを組み込み、アプリが自律的に精度を維持できるようにします。3点目は、対象系統の限定です。現在は7階冷房のみに特化しており、ビル全体を管理できません。今後は他フロアや暖房期を含めたマルチ系統の統合UIへと拡張し、ビル全体の省エネを一括管理できる基盤へと発展させていく予定です。</a:t>
             </a:r>
           </a:p>
         </p:txBody>
@@ -7472,8 +7472,8 @@
         </p:nvSpPr>
         <p:spPr>
           <a:xfrm>
-            <a:off x="507987" y="889000"/>
-            <a:ext cx="11175720" cy="5334000"/>
+            <a:off x="507987" y="825500"/>
+            <a:ext cx="11175720" cy="5461000"/>
           </a:xfrm>
           <a:prstGeom prst="rect">
             <a:avLst/>
@@ -7487,7 +7487,7 @@
           <a:lstStyle/>
           <a:p>
             <a:pPr>
-              <a:defRPr sz="1600" b="1">
+              <a:defRPr sz="1500" b="1">
                 <a:solidFill>
                   <a:srgbClr val="0B3968"/>
                 </a:solidFill>
@@ -7495,15 +7495,15 @@
               </a:defRPr>
             </a:pPr>
             <a:r>
-              <a:t>■ まとめ</a:t>
+              <a:t>■ まとめ（本実習での成果）</a:t>
             </a:r>
           </a:p>
           <a:p>
             <a:pPr>
               <a:spcAft>
-                <a:spcPts val="400"/>
+                <a:spcPts val="300"/>
               </a:spcAft>
-              <a:defRPr sz="1300">
+              <a:defRPr sz="1200">
                 <a:solidFill>
                   <a:srgbClr val="222222"/>
                 </a:solidFill>
@@ -7511,15 +7511,15 @@
               </a:defRPr>
             </a:pPr>
             <a:r>
-              <a:t>  ・過去のデータから外気温と室温を下げるのに必要な時間の関係を推測するモデルを作成し、それを用いて起動時間の決定、削減される電力量の推定までを行うことが可能になった</a:t>
+              <a:t>  ・気象予報から予冷時間を推計し、推奨起動時刻と削減電力量を提示するBM向け運用支援アプリを構築</a:t>
             </a:r>
           </a:p>
           <a:p>
             <a:pPr>
               <a:spcAft>
-                <a:spcPts val="400"/>
+                <a:spcPts val="300"/>
               </a:spcAft>
-              <a:defRPr sz="1300">
+              <a:defRPr sz="1200">
                 <a:solidFill>
                   <a:srgbClr val="222222"/>
                 </a:solidFill>
@@ -7527,15 +7527,15 @@
               </a:defRPr>
             </a:pPr>
             <a:r>
-              <a:t>  ・BM向けに明日の熱源起動時刻を決定する際の、判断材料となるような可視化アプリの作成を行った</a:t>
+              <a:t>  ・単に推奨値を出すだけでなく、安全マージン内訳やトレードオフ曲線を可視化し、BMが納得と安心感を持って判断できるUIを実現</a:t>
             </a:r>
           </a:p>
           <a:p>
             <a:pPr>
               <a:spcBef>
-                <a:spcPts val="1400"/>
+                <a:spcPts val="1000"/>
               </a:spcBef>
-              <a:defRPr sz="1600" b="1">
+              <a:defRPr sz="1500" b="1">
                 <a:solidFill>
                   <a:srgbClr val="0B3968"/>
                 </a:solidFill>
@@ -7543,15 +7543,15 @@
               </a:defRPr>
             </a:pPr>
             <a:r>
-              <a:t>■ 課題</a:t>
+              <a:t>■ 課題（実運用に向けたアプリ側の課題）</a:t>
             </a:r>
           </a:p>
           <a:p>
             <a:pPr>
               <a:spcAft>
-                <a:spcPts val="400"/>
+                <a:spcPts val="300"/>
               </a:spcAft>
-              <a:defRPr sz="1300">
+              <a:defRPr sz="1200">
                 <a:solidFill>
                   <a:srgbClr val="222222"/>
                 </a:solidFill>
@@ -7559,15 +7559,15 @@
               </a:defRPr>
             </a:pPr>
             <a:r>
-              <a:t>    1.  モデルの精度向上</a:t>
+              <a:t>    1. 実績振り返り機能の不足：翌朝「実際に何時に到達し、何kWh削減できたか」を画面上で確認・検証できない</a:t>
             </a:r>
           </a:p>
           <a:p>
             <a:pPr>
               <a:spcAft>
-                <a:spcPts val="400"/>
+                <a:spcPts val="300"/>
               </a:spcAft>
-              <a:defRPr sz="1300">
+              <a:defRPr sz="1200">
                 <a:solidFill>
                   <a:srgbClr val="222222"/>
                 </a:solidFill>
@@ -7575,15 +7575,31 @@
               </a:defRPr>
             </a:pPr>
             <a:r>
-              <a:t>    2.  暖房期への対応</a:t>
+              <a:t>    2. モデルの陳腐化リスク：運用データが蓄積されてもモデルが自動更新されず、季節遷移や経年変化に追従できない</a:t>
+            </a:r>
+          </a:p>
+          <a:p>
+            <a:pPr>
+              <a:spcAft>
+                <a:spcPts val="300"/>
+              </a:spcAft>
+              <a:defRPr sz="1200">
+                <a:solidFill>
+                  <a:srgbClr val="222222"/>
+                </a:solidFill>
+                <a:latin typeface="BIZ UDPGothic"/>
+              </a:defRPr>
+            </a:pPr>
+            <a:r>
+              <a:t>    3. 対象系統の限定（7階冷房のみ）：ビル全体の複数系統や他フロア、暖房期をまとめて1画面で俯瞰・操作できない</a:t>
             </a:r>
           </a:p>
           <a:p>
             <a:pPr>
               <a:spcBef>
-                <a:spcPts val="1400"/>
+                <a:spcPts val="1000"/>
               </a:spcBef>
-              <a:defRPr sz="1600" b="1">
+              <a:defRPr sz="1500" b="1">
                 <a:solidFill>
                   <a:srgbClr val="0B3968"/>
                 </a:solidFill>
@@ -7591,15 +7607,15 @@
               </a:defRPr>
             </a:pPr>
             <a:r>
-              <a:t>■ 今後の展望</a:t>
+              <a:t>■ 今後の展望（課題1〜3に対応）</a:t>
             </a:r>
           </a:p>
           <a:p>
             <a:pPr>
               <a:spcAft>
-                <a:spcPts val="400"/>
+                <a:spcPts val="300"/>
               </a:spcAft>
-              <a:defRPr sz="1300">
+              <a:defRPr sz="1200">
                 <a:solidFill>
                   <a:srgbClr val="222222"/>
                 </a:solidFill>
@@ -7607,15 +7623,15 @@
               </a:defRPr>
             </a:pPr>
             <a:r>
-              <a:t>    1.  データ読み取り→モデル再学習のサイクルの実装</a:t>
+              <a:t>    1. 省エネ実績ダッシュボードの実装：翌朝の実績を取り込んで予報とのズレや削減成果を自動表示し、運用の安心感を向上</a:t>
             </a:r>
           </a:p>
           <a:p>
             <a:pPr>
               <a:spcAft>
-                <a:spcPts val="400"/>
+                <a:spcPts val="300"/>
               </a:spcAft>
-              <a:defRPr sz="1300">
+              <a:defRPr sz="1200">
                 <a:solidFill>
                   <a:srgbClr val="222222"/>
                 </a:solidFill>
@@ -7623,7 +7639,23 @@
               </a:defRPr>
             </a:pPr>
             <a:r>
-              <a:t>    2.  冬季のデータをもとに暖房運転時の予測モデルの作成</a:t>
+              <a:t>    2. 自動データ蓄積・定期再学習サイクルの構築：日々のBEMSデータから定期的にモデルを自動再学習し、精度を自律維持</a:t>
+            </a:r>
+          </a:p>
+          <a:p>
+            <a:pPr>
+              <a:spcAft>
+                <a:spcPts val="300"/>
+              </a:spcAft>
+              <a:defRPr sz="1200">
+                <a:solidFill>
+                  <a:srgbClr val="222222"/>
+                </a:solidFill>
+                <a:latin typeface="BIZ UDPGothic"/>
+              </a:defRPr>
+            </a:pPr>
+            <a:r>
+              <a:t>    3. ビル全体のマルチ系統統合UIへの拡張：フロア切替や暖房期対応など、ビル全体の空調を一括管理できる統合基盤へ発展</a:t>
             </a:r>
           </a:p>
         </p:txBody>

</xml_diff>

<commit_message>
content(hvac): update slide 2 with enhanced flow diagram and visual accents
</commit_message>
<xml_diff>
--- a/public/slides/hvac-precooling-slides.pptx
+++ b/public/slides/hvac-precooling-slides.pptx
@@ -650,7 +650,7 @@
           <a:lstStyle/>
           <a:p>
             <a:r>
-              <a:t>背景と目的です。近年、脱炭素社会の実現やESG投資の拡大に伴い、ビル設備の省エネは企業価値に直結する重要課題となっています。当社ではシミュレーション技術を通じた脱炭素化と企業価値向上に取り組んでおり、その具体策の一つとしてオフィスビルの熱源起動時刻の最適化に着目しました。目指すのは、早朝予冷の無駄を削りつつ、始業時の快適性を確実に守ることです。ビルメンテナンス担当者が根拠を持って安全に起動時刻を判断できるよう、予冷時間予測から削減効果の可視化、意思決定までを支援するシステムを構築しました。</a:t>
+              <a:t>背景と目的です。近年、脱炭素社会の実現やESG投資の拡大に伴い、ビル設備の省エネは企業価値に直結する重要課題となっています。当社ではシミュレーション技術を通じた脱炭素化と企業価値向上に取り組んでおり、その具体策の一つとしてオフィスビルの熱源起動時刻の最適化に着目しました。しかし現場の実態としては、始業時の室温未達を恐れるあまり、早朝一律の過剰な予冷運転が行われ、電力が浪費されている現状があります。そこで本実習では、早朝予冷の無駄を削りつつ始業時の快適性を確実に守るため、データに基づく最適起動モデルを構築しました。さらに、気象予報から求めた予冷時間と削減効果を分かりやすく可視化し、現場のBM担当者が納得と安心感を持って翌朝の起動時刻を決められる意思決定支援システムを構築いたしました。</a:t>
             </a:r>
           </a:p>
         </p:txBody>
@@ -4995,8 +4995,8 @@
         </p:nvSpPr>
         <p:spPr>
           <a:xfrm>
-            <a:off x="571485" y="889000"/>
-            <a:ext cx="11048723" cy="5334000"/>
+            <a:off x="571485" y="825500"/>
+            <a:ext cx="7619809" cy="3810000"/>
           </a:xfrm>
           <a:prstGeom prst="rect">
             <a:avLst/>
@@ -5011,7 +5011,7 @@
           <a:p>
             <a:pPr>
               <a:spcAft>
-                <a:spcPts val="600"/>
+                <a:spcPts val="400"/>
               </a:spcAft>
               <a:defRPr sz="1600" b="1">
                 <a:solidFill>
@@ -5026,26 +5026,77 @@
           </a:p>
           <a:p>
             <a:pPr>
+              <a:spcAft>
+                <a:spcPts val="300"/>
+              </a:spcAft>
+              <a:defRPr sz="1200">
+                <a:solidFill>
+                  <a:srgbClr val="222222"/>
+                </a:solidFill>
+                <a:latin typeface="BIZ UDPGothic"/>
+              </a:defRPr>
+            </a:pPr>
+            <a:r>
+              <a:t>  ・近年、気候変動への対応や脱炭素に向け、ESG※1投資が世界的に拡大している</a:t>
+            </a:r>
+          </a:p>
+          <a:p>
+            <a:pPr>
+              <a:spcAft>
+                <a:spcPts val="300"/>
+              </a:spcAft>
+              <a:defRPr sz="1200">
+                <a:solidFill>
+                  <a:srgbClr val="222222"/>
+                </a:solidFill>
+                <a:latin typeface="BIZ UDPGothic"/>
+              </a:defRPr>
+            </a:pPr>
+            <a:r>
+              <a:t>  ・快適性とエネルギーに関してシミュレーション技術で脱炭素化と企業価値向上に貢献する</a:t>
+            </a:r>
+          </a:p>
+          <a:p>
+            <a:pPr>
+              <a:spcAft>
+                <a:spcPts val="300"/>
+              </a:spcAft>
+              <a:defRPr sz="1200">
+                <a:solidFill>
+                  <a:srgbClr val="222222"/>
+                </a:solidFill>
+                <a:latin typeface="BIZ UDPGothic"/>
+              </a:defRPr>
+            </a:pPr>
+            <a:r>
+              <a:t>  ・オフィスビルの熱源起動最適化に着目（※現場では未達を恐れ早朝一律の過剰予冷が発生）</a:t>
+            </a:r>
+          </a:p>
+          <a:p>
+            <a:pPr>
+              <a:spcBef>
+                <a:spcPts val="1200"/>
+              </a:spcBef>
               <a:spcAft>
                 <a:spcPts val="400"/>
               </a:spcAft>
-              <a:defRPr sz="1300">
-                <a:solidFill>
-                  <a:srgbClr val="222222"/>
-                </a:solidFill>
-                <a:latin typeface="BIZ UDPGothic"/>
-              </a:defRPr>
-            </a:pPr>
-            <a:r>
-              <a:t>  ・近年、気候変動への対応やカーボンニュートラルの実現に向け、ESG※1投資が世界的に拡大している</a:t>
+              <a:defRPr sz="1600" b="1">
+                <a:solidFill>
+                  <a:srgbClr val="0B3968"/>
+                </a:solidFill>
+                <a:latin typeface="BIZ UDPGothic"/>
+              </a:defRPr>
+            </a:pPr>
+            <a:r>
+              <a:t>■ 目的</a:t>
             </a:r>
           </a:p>
           <a:p>
             <a:pPr>
               <a:spcAft>
-                <a:spcPts val="400"/>
+                <a:spcPts val="300"/>
               </a:spcAft>
-              <a:defRPr sz="1300">
+              <a:defRPr sz="1200">
                 <a:solidFill>
                   <a:srgbClr val="222222"/>
                 </a:solidFill>
@@ -5053,15 +5104,15 @@
               </a:defRPr>
             </a:pPr>
             <a:r>
-              <a:t>  ・快適性とエネルギーに関してシミュレーション技術で脱炭素化と企業価値向上に貢献する</a:t>
+              <a:t>  ・空調熱源起動時刻をデータに基づいて最適化し、早朝予冷の無駄削減を目指す</a:t>
             </a:r>
           </a:p>
           <a:p>
             <a:pPr>
               <a:spcAft>
-                <a:spcPts val="400"/>
+                <a:spcPts val="300"/>
               </a:spcAft>
-              <a:defRPr sz="1300">
+              <a:defRPr sz="1200">
                 <a:solidFill>
                   <a:srgbClr val="222222"/>
                 </a:solidFill>
@@ -5069,66 +5120,15 @@
               </a:defRPr>
             </a:pPr>
             <a:r>
-              <a:t>  ・その中の一つとして、オフィスビルの熱源起動時刻の最適化を考える。</a:t>
-            </a:r>
-          </a:p>
-          <a:p>
-            <a:pPr>
-              <a:spcBef>
-                <a:spcPts val="1600"/>
-              </a:spcBef>
-              <a:spcAft>
-                <a:spcPts val="600"/>
-              </a:spcAft>
-              <a:defRPr sz="1600" b="1">
-                <a:solidFill>
-                  <a:srgbClr val="0B3968"/>
-                </a:solidFill>
-                <a:latin typeface="BIZ UDPGothic"/>
-              </a:defRPr>
-            </a:pPr>
-            <a:r>
-              <a:t>■ 目的</a:t>
+              <a:t>  ・それらの情報をわかりやすく可視化することで、ビルメンテナンス(BM)が根拠を持って</a:t>
             </a:r>
           </a:p>
           <a:p>
             <a:pPr>
               <a:spcAft>
-                <a:spcPts val="400"/>
+                <a:spcPts val="300"/>
               </a:spcAft>
-              <a:defRPr sz="1300">
-                <a:solidFill>
-                  <a:srgbClr val="222222"/>
-                </a:solidFill>
-                <a:latin typeface="BIZ UDPGothic"/>
-              </a:defRPr>
-            </a:pPr>
-            <a:r>
-              <a:t>  ・空調熱源起動時刻をデータに基づいて最適化し、早朝予冷の無駄削減を目指す</a:t>
-            </a:r>
-          </a:p>
-          <a:p>
-            <a:pPr>
-              <a:spcAft>
-                <a:spcPts val="400"/>
-              </a:spcAft>
-              <a:defRPr sz="1300">
-                <a:solidFill>
-                  <a:srgbClr val="222222"/>
-                </a:solidFill>
-                <a:latin typeface="BIZ UDPGothic"/>
-              </a:defRPr>
-            </a:pPr>
-            <a:r>
-              <a:t>  ・それらの情報をわかりやすく可視化することで、ビルメンテナンス(BM)が根拠を持って</a:t>
-            </a:r>
-          </a:p>
-          <a:p>
-            <a:pPr>
-              <a:spcAft>
-                <a:spcPts val="400"/>
-              </a:spcAft>
-              <a:defRPr sz="1300">
+              <a:defRPr sz="1200">
                 <a:solidFill>
                   <a:srgbClr val="222222"/>
                 </a:solidFill>
@@ -5149,8 +5149,102 @@
         </p:nvSpPr>
         <p:spPr>
           <a:xfrm>
-            <a:off x="2031949" y="4826000"/>
-            <a:ext cx="2158945" cy="762000"/>
+            <a:off x="8508787" y="1143000"/>
+            <a:ext cx="3174920" cy="1079500"/>
+          </a:xfrm>
+          <a:prstGeom prst="roundRect">
+            <a:avLst/>
+          </a:prstGeom>
+          <a:solidFill>
+            <a:srgbClr val="F8FAFC"/>
+          </a:solidFill>
+          <a:ln>
+            <a:solidFill>
+              <a:srgbClr val="CBD5E1"/>
+            </a:solidFill>
+          </a:ln>
+        </p:spPr>
+        <p:style>
+          <a:lnRef idx="1">
+            <a:schemeClr val="accent1"/>
+          </a:lnRef>
+          <a:fillRef idx="3">
+            <a:schemeClr val="accent1"/>
+          </a:fillRef>
+          <a:effectRef idx="2">
+            <a:schemeClr val="accent1"/>
+          </a:effectRef>
+          <a:fontRef idx="minor">
+            <a:schemeClr val="lt1"/>
+          </a:fontRef>
+        </p:style>
+        <p:txBody>
+          <a:bodyPr rtlCol="0" anchor="ctr" wrap="square"/>
+          <a:lstStyle/>
+          <a:p>
+            <a:pPr algn="ctr">
+              <a:defRPr sz="1000" b="1">
+                <a:solidFill>
+                  <a:srgbClr val="475569"/>
+                </a:solidFill>
+                <a:latin typeface="BIZ UDPGothic"/>
+              </a:defRPr>
+            </a:pPr>
+            <a:r>
+              <a:t>※1 ESG投資とは</a:t>
+            </a:r>
+          </a:p>
+          <a:p>
+            <a:pPr>
+              <a:defRPr sz="900">
+                <a:solidFill>
+                  <a:srgbClr val="64748B"/>
+                </a:solidFill>
+                <a:latin typeface="BIZ UDPGothic"/>
+              </a:defRPr>
+            </a:pPr>
+            <a:r>
+              <a:t>E(環境)：気候変動・省エネなど</a:t>
+            </a:r>
+          </a:p>
+          <a:p>
+            <a:pPr>
+              <a:defRPr sz="900">
+                <a:solidFill>
+                  <a:srgbClr val="64748B"/>
+                </a:solidFill>
+                <a:latin typeface="BIZ UDPGothic"/>
+              </a:defRPr>
+            </a:pPr>
+            <a:r>
+              <a:t>S(社会)：快適性・働き方改善など</a:t>
+            </a:r>
+          </a:p>
+          <a:p>
+            <a:pPr>
+              <a:defRPr sz="900">
+                <a:solidFill>
+                  <a:srgbClr val="64748B"/>
+                </a:solidFill>
+                <a:latin typeface="BIZ UDPGothic"/>
+              </a:defRPr>
+            </a:pPr>
+            <a:r>
+              <a:t>G(ガバナンス)：法令遵守・管理規則など</a:t>
+            </a:r>
+          </a:p>
+        </p:txBody>
+      </p:sp>
+      <p:sp>
+        <p:nvSpPr>
+          <p:cNvPr id="9" name="Rounded Rectangle 8"/>
+          <p:cNvSpPr/>
+          <p:nvPr/>
+        </p:nvSpPr>
+        <p:spPr>
+          <a:xfrm>
+            <a:off x="1206469" y="4762500"/>
+            <a:ext cx="2857428" cy="889000"/>
           </a:xfrm>
           <a:prstGeom prst="roundRect">
             <a:avLst/>
@@ -5179,11 +5273,11 @@
           </a:fontRef>
         </p:style>
         <p:txBody>
-          <a:bodyPr rtlCol="0" anchor="ctr"/>
+          <a:bodyPr rtlCol="0" anchor="ctr" wrap="square"/>
           <a:lstStyle/>
           <a:p>
             <a:pPr algn="ctr">
-              <a:defRPr sz="1200" b="1">
+              <a:defRPr sz="1300" b="1">
                 <a:solidFill>
                   <a:srgbClr val="0B3968"/>
                 </a:solidFill>
@@ -5191,26 +5285,34 @@
               </a:defRPr>
             </a:pPr>
             <a:r>
-              <a:t>必要な</a:t>
-            </a:r>
-          </a:p>
-          <a:p>
-            <a:r>
-              <a:t>予冷時間の予測</a:t>
-            </a:r>
-          </a:p>
-        </p:txBody>
-      </p:sp>
-      <p:sp>
-        <p:nvSpPr>
-          <p:cNvPr id="9" name="Rounded Rectangle 8"/>
+              <a:t>必要な予冷時間の予測</a:t>
+            </a:r>
+          </a:p>
+          <a:p>
+            <a:pPr algn="ctr">
+              <a:defRPr sz="1000">
+                <a:solidFill>
+                  <a:srgbClr val="555555"/>
+                </a:solidFill>
+                <a:latin typeface="BIZ UDPGothic"/>
+              </a:defRPr>
+            </a:pPr>
+            <a:r>
+              <a:t>気象予報 × 回帰モデル</a:t>
+            </a:r>
+          </a:p>
+        </p:txBody>
+      </p:sp>
+      <p:sp>
+        <p:nvSpPr>
+          <p:cNvPr id="10" name="Rounded Rectangle 9"/>
           <p:cNvSpPr/>
           <p:nvPr/>
         </p:nvSpPr>
         <p:spPr>
           <a:xfrm>
-            <a:off x="5206869" y="4826000"/>
-            <a:ext cx="2158945" cy="762000"/>
+            <a:off x="4889377" y="4762500"/>
+            <a:ext cx="2857428" cy="889000"/>
           </a:xfrm>
           <a:prstGeom prst="roundRect">
             <a:avLst/>
@@ -5239,11 +5341,11 @@
           </a:fontRef>
         </p:style>
         <p:txBody>
-          <a:bodyPr rtlCol="0" anchor="ctr"/>
+          <a:bodyPr rtlCol="0" anchor="ctr" wrap="square"/>
           <a:lstStyle/>
           <a:p>
             <a:pPr algn="ctr">
-              <a:defRPr sz="1200" b="1">
+              <a:defRPr sz="1300" b="1">
                 <a:solidFill>
                   <a:srgbClr val="0B3968"/>
                 </a:solidFill>
@@ -5251,26 +5353,34 @@
               </a:defRPr>
             </a:pPr>
             <a:r>
-              <a:t>削減効果の</a:t>
-            </a:r>
-          </a:p>
-          <a:p>
-            <a:r>
-              <a:t>可視化</a:t>
-            </a:r>
-          </a:p>
-        </p:txBody>
-      </p:sp>
-      <p:sp>
-        <p:nvSpPr>
-          <p:cNvPr id="10" name="Rounded Rectangle 9"/>
+              <a:t>削減効果の可視化</a:t>
+            </a:r>
+          </a:p>
+          <a:p>
+            <a:pPr algn="ctr">
+              <a:defRPr sz="1000">
+                <a:solidFill>
+                  <a:srgbClr val="555555"/>
+                </a:solidFill>
+                <a:latin typeface="BIZ UDPGothic"/>
+              </a:defRPr>
+            </a:pPr>
+            <a:r>
+              <a:t>トレードオフ曲線・UI</a:t>
+            </a:r>
+          </a:p>
+        </p:txBody>
+      </p:sp>
+      <p:sp>
+        <p:nvSpPr>
+          <p:cNvPr id="11" name="Rounded Rectangle 10"/>
           <p:cNvSpPr/>
           <p:nvPr/>
         </p:nvSpPr>
         <p:spPr>
           <a:xfrm>
-            <a:off x="8381790" y="4826000"/>
-            <a:ext cx="2158945" cy="762000"/>
+            <a:off x="8572285" y="4762500"/>
+            <a:ext cx="2857428" cy="889000"/>
           </a:xfrm>
           <a:prstGeom prst="roundRect">
             <a:avLst/>
@@ -5299,11 +5409,11 @@
           </a:fontRef>
         </p:style>
         <p:txBody>
-          <a:bodyPr rtlCol="0" anchor="ctr"/>
+          <a:bodyPr rtlCol="0" anchor="ctr" wrap="square"/>
           <a:lstStyle/>
           <a:p>
             <a:pPr algn="ctr">
-              <a:defRPr sz="1200" b="1">
+              <a:defRPr sz="1300" b="1">
                 <a:solidFill>
                   <a:srgbClr val="0B3968"/>
                 </a:solidFill>
@@ -5311,12 +5421,20 @@
               </a:defRPr>
             </a:pPr>
             <a:r>
-              <a:t>BM</a:t>
-            </a:r>
-          </a:p>
-          <a:p>
-            <a:r>
-              <a:t>意思決定</a:t>
+              <a:t>BM 意思決定</a:t>
+            </a:r>
+          </a:p>
+          <a:p>
+            <a:pPr algn="ctr">
+              <a:defRPr sz="1000">
+                <a:solidFill>
+                  <a:srgbClr val="555555"/>
+                </a:solidFill>
+                <a:latin typeface="BIZ UDPGothic"/>
+              </a:defRPr>
+            </a:pPr>
+            <a:r>
+              <a:t>安心・納得の起動判断</a:t>
             </a:r>
           </a:p>
         </p:txBody>

</xml_diff>

<commit_message>
content(hvac): update slide 8 with polished impressions and photo captions
</commit_message>
<xml_diff>
--- a/public/slides/hvac-precooling-slides.pptx
+++ b/public/slides/hvac-precooling-slides.pptx
@@ -1070,7 +1070,7 @@
           <a:lstStyle/>
           <a:p>
             <a:r>
-              <a:t>最後に、2週間の実習を通した所感です。今回、現場の担当者がどう判断するかという「お客様目線」での開発に取り組み、単にアルゴリズムを作るだけでなく、相手のニーズを汲み取って安全側マージンや可視化画面を設計することの難しさと重要性を深く学びました。また、実際の設備現場や実験住宅の見学など、机上のプログラミングにとどまらない貴重な体験をさせていただき、自分の技術が脱炭素や社会貢献につながるという強い実感を得ることができました。ご指導いただいたメンターの皆様、関係者の皆様に心より感謝申し上げます。ご清聴ありがとうございました。</a:t>
+              <a:t>最後に、2週間の実習を通した所感です。初日の自己紹介で挙げた「3つの参加理由」に対し、期待を大きく超える充実した学びを得ることができました。まず開発面では、単に予測モデルを作るだけでなく、現場のBM担当者がどうすれば安心して起動を遅らせられるかという「お客様目線」でのUI・安全マージン設計の難しさと重要性を深く学びました。また、大学では扱えない実機データに触れる中で、シミュレーション技術が脱炭素や社会貢献に直結しているという強い手応えを得ることができました。そしてインターンシップ全体を通じ、デスクワークにとどまらず実験住宅やセキュリティ現場の見学など幅広い体験をさせていただき、当社の高い技術力と現場主義の社風を肌で体感いたしました。親身にご指導いただいたメンターの皆様、関係者の皆様に心より感謝申し上げます。2週間、本当にありがとうございました。</a:t>
             </a:r>
           </a:p>
         </p:txBody>
@@ -8017,8 +8017,8 @@
         </p:nvSpPr>
         <p:spPr>
           <a:xfrm>
-            <a:off x="444488" y="889000"/>
-            <a:ext cx="5333866" cy="5334000"/>
+            <a:off x="444488" y="825500"/>
+            <a:ext cx="5079872" cy="5461000"/>
           </a:xfrm>
           <a:prstGeom prst="rect">
             <a:avLst/>
@@ -8032,7 +8032,7 @@
           <a:lstStyle/>
           <a:p>
             <a:pPr>
-              <a:defRPr sz="1600" b="1">
+              <a:defRPr sz="1500" b="1">
                 <a:solidFill>
                   <a:srgbClr val="0B3968"/>
                 </a:solidFill>
@@ -8040,15 +8040,28 @@
               </a:defRPr>
             </a:pPr>
             <a:r>
-              <a:t>■ 実習を通して</a:t>
+              <a:t>■ 実習を通して（技術・開発の学び）</a:t>
+            </a:r>
+          </a:p>
+          <a:p>
+            <a:pPr>
+              <a:defRPr sz="1200" b="1">
+                <a:solidFill>
+                  <a:srgbClr val="00509E"/>
+                </a:solidFill>
+                <a:latin typeface="BIZ UDPGothic"/>
+              </a:defRPr>
+            </a:pPr>
+            <a:r>
+              <a:t>  ・お客様目線での開発</a:t>
             </a:r>
           </a:p>
           <a:p>
             <a:pPr>
               <a:spcAft>
-                <a:spcPts val="400"/>
+                <a:spcPts val="200"/>
               </a:spcAft>
-              <a:defRPr sz="1200">
+              <a:defRPr sz="1100">
                 <a:solidFill>
                   <a:srgbClr val="222222"/>
                 </a:solidFill>
@@ -8056,15 +8069,28 @@
               </a:defRPr>
             </a:pPr>
             <a:r>
-              <a:t>  ・お客様目線でのアプリケーション開発では、相手のニーズを想定しながら進める必要があり、難しさを感じた</a:t>
+              <a:t>    現場のBM担当者が安心できるマージンやUIを追求する難しさと重要性を学んだ</a:t>
+            </a:r>
+          </a:p>
+          <a:p>
+            <a:pPr>
+              <a:defRPr sz="1200" b="1">
+                <a:solidFill>
+                  <a:srgbClr val="00509E"/>
+                </a:solidFill>
+                <a:latin typeface="BIZ UDPGothic"/>
+              </a:defRPr>
+            </a:pPr>
+            <a:r>
+              <a:t>  ・社会貢献の実感</a:t>
             </a:r>
           </a:p>
           <a:p>
             <a:pPr>
               <a:spcAft>
-                <a:spcPts val="400"/>
+                <a:spcPts val="200"/>
               </a:spcAft>
-              <a:defRPr sz="1200">
+              <a:defRPr sz="1100">
                 <a:solidFill>
                   <a:srgbClr val="222222"/>
                 </a:solidFill>
@@ -8072,15 +8098,15 @@
               </a:defRPr>
             </a:pPr>
             <a:r>
-              <a:t>  ・実際のデータやその現場を見に行くことで、社会貢献ができるという意識を感じることができた</a:t>
+              <a:t>    実機・現場データに触れ、技術が脱炭素という社会貢献に直結する手応えを得た</a:t>
             </a:r>
           </a:p>
           <a:p>
             <a:pPr>
               <a:spcBef>
-                <a:spcPts val="1400"/>
+                <a:spcPts val="800"/>
               </a:spcBef>
-              <a:defRPr sz="1600" b="1">
+              <a:defRPr sz="1500" b="1">
                 <a:solidFill>
                   <a:srgbClr val="0B3968"/>
                 </a:solidFill>
@@ -8088,15 +8114,28 @@
               </a:defRPr>
             </a:pPr>
             <a:r>
-              <a:t>■ インターンシップを通して</a:t>
+              <a:t>■ インターンシップを通して（社風・現場体験）</a:t>
+            </a:r>
+          </a:p>
+          <a:p>
+            <a:pPr>
+              <a:defRPr sz="1200" b="1">
+                <a:solidFill>
+                  <a:srgbClr val="00509E"/>
+                </a:solidFill>
+                <a:latin typeface="BIZ UDPGothic"/>
+              </a:defRPr>
+            </a:pPr>
+            <a:r>
+              <a:t>  ・現場主義の社風を実感</a:t>
             </a:r>
           </a:p>
           <a:p>
             <a:pPr>
               <a:spcAft>
-                <a:spcPts val="400"/>
+                <a:spcPts val="200"/>
               </a:spcAft>
-              <a:defRPr sz="1200">
+              <a:defRPr sz="1100">
                 <a:solidFill>
                   <a:srgbClr val="222222"/>
                 </a:solidFill>
@@ -8104,15 +8143,28 @@
               </a:defRPr>
             </a:pPr>
             <a:r>
-              <a:t>  ・実際の会社の肌で感じることができた。</a:t>
+              <a:t>    実験住宅やセキュリティ見学など生活を支える高い技術力を肌で体感できた</a:t>
+            </a:r>
+          </a:p>
+          <a:p>
+            <a:pPr>
+              <a:defRPr sz="1200" b="1">
+                <a:solidFill>
+                  <a:srgbClr val="00509E"/>
+                </a:solidFill>
+                <a:latin typeface="BIZ UDPGothic"/>
+              </a:defRPr>
+            </a:pPr>
+            <a:r>
+              <a:t>  ・感謝</a:t>
             </a:r>
           </a:p>
           <a:p>
             <a:pPr>
               <a:spcAft>
-                <a:spcPts val="400"/>
+                <a:spcPts val="200"/>
               </a:spcAft>
-              <a:defRPr sz="1200">
+              <a:defRPr sz="1100">
                 <a:solidFill>
                   <a:srgbClr val="222222"/>
                 </a:solidFill>
@@ -8120,7 +8172,7 @@
               </a:defRPr>
             </a:pPr>
             <a:r>
-              <a:t>  ・デスクワークにとどまらず、実験住宅の見学やセキュリティ関連のご紹介など、幅広い体験ができ、大変充実した2週間を過ごすことができました</a:t>
+              <a:t>    親身にご指導くださったメンターの皆様に感謝申し上げます。大変充実した2週間となりました</a:t>
             </a:r>
           </a:p>
         </p:txBody>
@@ -8141,17 +8193,53 @@
         </p:blipFill>
         <p:spPr>
           <a:xfrm>
-            <a:off x="6730831" y="889000"/>
-            <a:ext cx="2730431" cy="2540000"/>
+            <a:off x="6730831" y="825500"/>
+            <a:ext cx="2793930" cy="2413000"/>
           </a:xfrm>
           <a:prstGeom prst="rect">
             <a:avLst/>
           </a:prstGeom>
         </p:spPr>
       </p:pic>
+      <p:sp>
+        <p:nvSpPr>
+          <p:cNvPr id="9" name="TextBox 8"/>
+          <p:cNvSpPr txBox="1"/>
+          <p:nvPr/>
+        </p:nvSpPr>
+        <p:spPr>
+          <a:xfrm>
+            <a:off x="6730831" y="3238500"/>
+            <a:ext cx="2793930" cy="317500"/>
+          </a:xfrm>
+          <a:prstGeom prst="rect">
+            <a:avLst/>
+          </a:prstGeom>
+          <a:noFill/>
+        </p:spPr>
+        <p:txBody>
+          <a:bodyPr wrap="none">
+            <a:spAutoFit/>
+          </a:bodyPr>
+          <a:lstStyle/>
+          <a:p>
+            <a:pPr algn="ctr">
+              <a:defRPr sz="900" b="1">
+                <a:solidFill>
+                  <a:srgbClr val="555555"/>
+                </a:solidFill>
+                <a:latin typeface="BIZ UDPGothic"/>
+              </a:defRPr>
+            </a:pPr>
+            <a:r>
+              <a:t>【パナソニック受付にて】</a:t>
+            </a:r>
+          </a:p>
+        </p:txBody>
+      </p:sp>
       <p:pic>
         <p:nvPicPr>
-          <p:cNvPr id="9" name="Picture 8" descr="onsite_photo_building.png"/>
+          <p:cNvPr id="10" name="Picture 9" descr="onsite_photo_building.png"/>
           <p:cNvPicPr>
             <a:picLocks noChangeAspect="1"/>
           </p:cNvPicPr>
@@ -8165,17 +8253,53 @@
         </p:blipFill>
         <p:spPr>
           <a:xfrm>
-            <a:off x="5460863" y="3048000"/>
-            <a:ext cx="2285942" cy="2730500"/>
+            <a:off x="5333866" y="3556000"/>
+            <a:ext cx="2285942" cy="2413000"/>
           </a:xfrm>
           <a:prstGeom prst="rect">
             <a:avLst/>
           </a:prstGeom>
         </p:spPr>
       </p:pic>
+      <p:sp>
+        <p:nvSpPr>
+          <p:cNvPr id="11" name="TextBox 10"/>
+          <p:cNvSpPr txBox="1"/>
+          <p:nvPr/>
+        </p:nvSpPr>
+        <p:spPr>
+          <a:xfrm>
+            <a:off x="5333866" y="5994400"/>
+            <a:ext cx="2285942" cy="317500"/>
+          </a:xfrm>
+          <a:prstGeom prst="rect">
+            <a:avLst/>
+          </a:prstGeom>
+          <a:noFill/>
+        </p:spPr>
+        <p:txBody>
+          <a:bodyPr wrap="none">
+            <a:spAutoFit/>
+          </a:bodyPr>
+          <a:lstStyle/>
+          <a:p>
+            <a:pPr algn="ctr">
+              <a:defRPr sz="900" b="1">
+                <a:solidFill>
+                  <a:srgbClr val="555555"/>
+                </a:solidFill>
+                <a:latin typeface="BIZ UDPGothic"/>
+              </a:defRPr>
+            </a:pPr>
+            <a:r>
+              <a:t>【実験住宅・設備見学】</a:t>
+            </a:r>
+          </a:p>
+        </p:txBody>
+      </p:sp>
       <p:pic>
         <p:nvPicPr>
-          <p:cNvPr id="10" name="Picture 9" descr="onsite_photo_living.png"/>
+          <p:cNvPr id="12" name="Picture 11" descr="onsite_photo_living.png"/>
           <p:cNvPicPr>
             <a:picLocks noChangeAspect="1"/>
           </p:cNvPicPr>
@@ -8189,14 +8313,50 @@
         </p:blipFill>
         <p:spPr>
           <a:xfrm>
-            <a:off x="7429314" y="3746500"/>
-            <a:ext cx="2984425" cy="2095500"/>
+            <a:off x="7810304" y="3810000"/>
+            <a:ext cx="2857428" cy="2159000"/>
           </a:xfrm>
           <a:prstGeom prst="rect">
             <a:avLst/>
           </a:prstGeom>
         </p:spPr>
       </p:pic>
+      <p:sp>
+        <p:nvSpPr>
+          <p:cNvPr id="13" name="TextBox 12"/>
+          <p:cNvSpPr txBox="1"/>
+          <p:nvPr/>
+        </p:nvSpPr>
+        <p:spPr>
+          <a:xfrm>
+            <a:off x="7810304" y="5994400"/>
+            <a:ext cx="2857428" cy="317500"/>
+          </a:xfrm>
+          <a:prstGeom prst="rect">
+            <a:avLst/>
+          </a:prstGeom>
+          <a:noFill/>
+        </p:spPr>
+        <p:txBody>
+          <a:bodyPr wrap="none">
+            <a:spAutoFit/>
+          </a:bodyPr>
+          <a:lstStyle/>
+          <a:p>
+            <a:pPr algn="ctr">
+              <a:defRPr sz="900" b="1">
+                <a:solidFill>
+                  <a:srgbClr val="555555"/>
+                </a:solidFill>
+                <a:latin typeface="BIZ UDPGothic"/>
+              </a:defRPr>
+            </a:pPr>
+            <a:r>
+              <a:t>【スマートハウス空間体験】</a:t>
+            </a:r>
+          </a:p>
+        </p:txBody>
+      </p:sp>
     </p:spTree>
   </p:cSld>
   <p:clrMapOvr>

</xml_diff>

<commit_message>
content(hvac): reinforce logical connections in slides 4, 5, and 6
</commit_message>
<xml_diff>
--- a/public/slides/hvac-precooling-slides.pptx
+++ b/public/slides/hvac-precooling-slides.pptx
@@ -790,7 +790,7 @@
           <a:lstStyle/>
           <a:p>
             <a:r>
-              <a:t>次に、モデル設計にあたって現場の判断材料をどのように求めたかをご説明します。担当者が前日に知りたいのは、「明日の何時に起動すれば、何時に設定温度に到達するか」です。そこで、過去データから予冷時間を推計するモデルを構築しました。式の基本構造は、外気温と設定温度から求めるベース予冷時間に、安全マージンを加える形です。外気温には前日夕方に取得できる天気予報を用い、設定温度は任意に変更可能としています。また、朝は起動をやり直せないため、予報誤差やモデル精度を見込んだ安全マージンを上乗せして確実に間に合わせます。さらに、休み明けは躯体に熱が残って室温が約2℃高いことが分かったため、外気温に+2℃のオフセットをかけて同じモデルに通す工夫を行いました。</a:t>
+              <a:t>次に、モデル設計にあたって現場の判断材料をどのように求めたかをご説明します。担当者が前日に知りたいのは、「明日の何時に起動すれば、何時に設定温度に到達するか」です。予冷時間は本来、冷やす直前の「室温」に大きく左右されますが、起動時刻を決める前日夕方の時点では翌朝の室温は分かりません。そこで、前日に確実に取得できる天気予報の外気温情報から、直接予冷時間を推計するモデル構造といたしました。式の基本構造は、外気温と設定温度から求めるベース予冷時間に、安全マージンを加える形です。また、朝は起動のやり直しがきかないため、予報誤差やモデル精度を見込んだ安全マージンを上乗せして確実に間に合わせます。さらに、休み明けは躯体に熱が残って室温が約2℃高いことが分かったため、外気温に+2℃のオフセットをかけて同じモデルに通す工夫を行いました。</a:t>
             </a:r>
           </a:p>
         </p:txBody>
@@ -860,7 +860,7 @@
           <a:lstStyle/>
           <a:p>
             <a:r>
-              <a:t>開発した最適起動モデルを実データに適用した、バックテスト検証結果です。過去データの実測気温推移からモデルで起動時刻を決定し直したところ、全日で8:00始業前の設定温度到達を達成できました。効果として、まず運転時間は平均で約104分短縮され、最大で1時間40分ほど起動を遅らせることができました。その結果、始業前の消費電力量は平均で約36%削減できることを確認いたしました。</a:t>
+              <a:t>開発した最適起動モデルを実データに適用した、バックテスト検証結果です。過去データの実測気温推移からモデルで予冷時間を推計し、始業8:00から逆算して、確実に間に合う範囲で最も遅い起動時刻を決定し直しました。その結果、全日で8:00始業前の設定温度到達を達成できました。効果として、まず運転時間は平均で約104分短縮され、最大で1時間40分ほど起動を遅らせることができました。その結果、始業前の消費電力量は平均で約36%削減できることを確認いたしました。</a:t>
             </a:r>
           </a:p>
         </p:txBody>
@@ -930,7 +930,7 @@
           <a:lstStyle/>
           <a:p>
             <a:r>
-              <a:t>続いて、現場のビルメンテナンス担当者が実際に使用する可視化アプリです。担当者が夕方に翌日の日付を選ぶだけで、天気予報を自動取得し、推奨起動時刻（例えば07:10など）を算出して提示します。単に推奨時刻を出すだけでなく、二軸のトレードオフ曲線によって「起動を早めると電力を消費し、遅らせると到達リスクが高まる」という関係を可視化しています。これにより、担当者が納得感と安心感を持って翌日の起動時刻を決定できます。また、予報気温が過去データの範囲を超える場合は外挿警告を出し、担当者に判断を委ねる安全設計としています。</a:t>
+              <a:t>続いて、スライド5で実証された高い削減効果を、現場のBM担当者が毎日根拠を持って再現できるように開発した「可視化アプリ」です。担当者が夕方に翌日の日付を選ぶだけで、天気予報を自動取得し、推奨起動時刻（例えば07:10など）を算出して提示します。単に推奨時刻を押し付けるのではなく、二軸のトレードオフ曲線によって「起動を早めると電力を消費し、遅らせると到達リスクが高まる」という関係を可視化しています。これにより、担当者が納得感と安心感を持って翌日の起動時刻を決定できます。また、予報気温が過去データの範囲を超える場合は外挿警告を出し、担当者に判断を委ねる安全設計としています。</a:t>
             </a:r>
           </a:p>
         </p:txBody>
@@ -6293,6 +6293,19 @@
           </a:p>
           <a:p>
             <a:pPr>
+              <a:defRPr sz="950">
+                <a:solidFill>
+                  <a:srgbClr val="555555"/>
+                </a:solidFill>
+                <a:latin typeface="BIZ UDPGothic"/>
+              </a:defRPr>
+            </a:pPr>
+            <a:r>
+              <a:t>       （※決定時点では翌朝の室温が不明なため、予報外気温から直接推計）</a:t>
+            </a:r>
+          </a:p>
+          <a:p>
+            <a:pPr>
               <a:defRPr sz="1200" b="1">
                 <a:solidFill>
                   <a:srgbClr val="00509E"/>
@@ -6346,7 +6359,7 @@
           <a:p>
             <a:pPr>
               <a:spcBef>
-                <a:spcPts val="800"/>
+                <a:spcPts val="600"/>
               </a:spcBef>
               <a:defRPr sz="1500" b="1">
                 <a:solidFill>
@@ -6663,8 +6676,8 @@
         </p:nvSpPr>
         <p:spPr>
           <a:xfrm>
-            <a:off x="444488" y="762000"/>
-            <a:ext cx="11302717" cy="762000"/>
+            <a:off x="444488" y="698500"/>
+            <a:ext cx="11302717" cy="889000"/>
           </a:xfrm>
           <a:prstGeom prst="rect">
             <a:avLst/>
@@ -6691,7 +6704,7 @@
           </a:p>
           <a:p>
             <a:pPr>
-              <a:defRPr sz="1300">
+              <a:defRPr sz="1200">
                 <a:solidFill>
                   <a:srgbClr val="222222"/>
                 </a:solidFill>
@@ -6700,6 +6713,19 @@
             </a:pPr>
             <a:r>
               <a:t>  ・作成した予測モデルを用い、実際の過去データの気温推移から必要な予冷時間を推測、起動時間を決定した</a:t>
+            </a:r>
+          </a:p>
+          <a:p>
+            <a:pPr>
+              <a:defRPr sz="1000">
+                <a:solidFill>
+                  <a:srgbClr val="555555"/>
+                </a:solidFill>
+                <a:latin typeface="BIZ UDPGothic"/>
+              </a:defRPr>
+            </a:pPr>
+            <a:r>
+              <a:t>     （※始業8:00から予冷時間を逆算し、確実に到達できる最も遅い起動時刻を算出）</a:t>
             </a:r>
           </a:p>
         </p:txBody>

</xml_diff>

<commit_message>
content(hvac): update slide 2 with purpose-first layout
</commit_message>
<xml_diff>
--- a/public/slides/hvac-precooling-slides.pptx
+++ b/public/slides/hvac-precooling-slides.pptx
@@ -650,7 +650,7 @@
           <a:lstStyle/>
           <a:p>
             <a:r>
-              <a:t>背景と目的です。近年、脱炭素社会の実現やESG投資の拡大に伴い、ビル設備の省エネは企業価値に直結する重要課題となっています。当社ではシミュレーション技術を通じた脱炭素化と企業価値向上に取り組んでおり、その具体策の一つとしてオフィスビルの熱源起動時刻の最適化に着目しました。しかし現場の実態としては、始業時の室温未達を恐れるあまり、早朝一律の過剰な予冷運転が行われ、電力が浪費されている現状があります。そこで本実習では、早朝予冷の無駄を削りつつ始業時の快適性を確実に守るため、データに基づく最適起動モデルを構築しました。さらに、気象予報から求めた予冷時間と削減効果を分かりやすく可視化し、現場のBM担当者が納得と安心感を持って翌朝の起動時刻を決められる意思決定支援システムを構築いたしました。</a:t>
+              <a:t>目的と背景です。まず本実習の目的として、空調熱源の起動時刻をデータに基づいて最適化し、早朝予冷の無駄削減を目指しました。具体的には、ビルメンテナンス担当者が納得と安心感を持って安全に起動時刻を判断できるよう、スライドのフロー図に示す「必要な予冷時間の予測」「削減効果の可視化」「BMの意思決定支援」という3ステップのシステムを構築いたしました。この取り組みの背景には、2つの大きな要因があります。1つ目は社会的要請です。近年、気候変動対応や脱炭素化に伴いESG投資が世界的に拡大しており、当社でもシミュレーション技術を通じた脱炭素化と企業価値向上に注力しています。そして2つ目が現場の実態です。実際のビル運用現場では、始業時の室温未達クレームを恐れるあまり、早朝一律の過剰な予冷運転が行われ、電力が浪費されている現状がありました。そこで、この現場の課題を解決し、脱炭素へ貢献するために本システムの開発に取り組みました。</a:t>
             </a:r>
           </a:p>
         </p:txBody>
@@ -4995,8 +4995,8 @@
         </p:nvSpPr>
         <p:spPr>
           <a:xfrm>
-            <a:off x="571485" y="825500"/>
-            <a:ext cx="7619809" cy="3810000"/>
+            <a:off x="571485" y="762000"/>
+            <a:ext cx="11048723" cy="1016000"/>
           </a:xfrm>
           <a:prstGeom prst="rect">
             <a:avLst/>
@@ -5011,9 +5011,284 @@
           <a:p>
             <a:pPr>
               <a:spcAft>
+                <a:spcPts val="200"/>
+              </a:spcAft>
+              <a:defRPr sz="1500" b="1">
+                <a:solidFill>
+                  <a:srgbClr val="0B3968"/>
+                </a:solidFill>
+                <a:latin typeface="BIZ UDPGothic"/>
+              </a:defRPr>
+            </a:pPr>
+            <a:r>
+              <a:t>■ 目的（本実習で目指したこと）</a:t>
+            </a:r>
+          </a:p>
+          <a:p>
+            <a:pPr>
+              <a:spcAft>
+                <a:spcPts val="200"/>
+              </a:spcAft>
+              <a:defRPr sz="1200">
+                <a:solidFill>
+                  <a:srgbClr val="222222"/>
+                </a:solidFill>
+                <a:latin typeface="BIZ UDPGothic"/>
+              </a:defRPr>
+            </a:pPr>
+            <a:r>
+              <a:t>  ・空調熱源起動時刻をデータに基づいて最適化し、早朝予冷の無駄削減を目指す</a:t>
+            </a:r>
+          </a:p>
+          <a:p>
+            <a:pPr>
+              <a:spcAft>
+                <a:spcPts val="200"/>
+              </a:spcAft>
+              <a:defRPr sz="1200">
+                <a:solidFill>
+                  <a:srgbClr val="222222"/>
+                </a:solidFill>
+                <a:latin typeface="BIZ UDPGothic"/>
+              </a:defRPr>
+            </a:pPr>
+            <a:r>
+              <a:t>  ・ビルメンテナンス(BM)が根拠を持って安全に起動時刻を判断できる意思決定支援システムを構築する</a:t>
+            </a:r>
+          </a:p>
+        </p:txBody>
+      </p:sp>
+      <p:sp>
+        <p:nvSpPr>
+          <p:cNvPr id="8" name="Rounded Rectangle 7"/>
+          <p:cNvSpPr/>
+          <p:nvPr/>
+        </p:nvSpPr>
+        <p:spPr>
+          <a:xfrm>
+            <a:off x="1206469" y="1841500"/>
+            <a:ext cx="2857428" cy="838200"/>
+          </a:xfrm>
+          <a:prstGeom prst="roundRect">
+            <a:avLst/>
+          </a:prstGeom>
+          <a:solidFill>
+            <a:srgbClr val="EDF5FB"/>
+          </a:solidFill>
+          <a:ln>
+            <a:solidFill>
+              <a:srgbClr val="7BA4C7"/>
+            </a:solidFill>
+          </a:ln>
+        </p:spPr>
+        <p:style>
+          <a:lnRef idx="1">
+            <a:schemeClr val="accent1"/>
+          </a:lnRef>
+          <a:fillRef idx="3">
+            <a:schemeClr val="accent1"/>
+          </a:fillRef>
+          <a:effectRef idx="2">
+            <a:schemeClr val="accent1"/>
+          </a:effectRef>
+          <a:fontRef idx="minor">
+            <a:schemeClr val="lt1"/>
+          </a:fontRef>
+        </p:style>
+        <p:txBody>
+          <a:bodyPr rtlCol="0" anchor="ctr" wrap="square"/>
+          <a:lstStyle/>
+          <a:p>
+            <a:pPr algn="ctr">
+              <a:defRPr sz="1300" b="1">
+                <a:solidFill>
+                  <a:srgbClr val="0B3968"/>
+                </a:solidFill>
+                <a:latin typeface="BIZ UDPGothic"/>
+              </a:defRPr>
+            </a:pPr>
+            <a:r>
+              <a:t>必要な予冷時間の予測</a:t>
+            </a:r>
+          </a:p>
+          <a:p>
+            <a:pPr algn="ctr">
+              <a:defRPr sz="1000">
+                <a:solidFill>
+                  <a:srgbClr val="555555"/>
+                </a:solidFill>
+                <a:latin typeface="BIZ UDPGothic"/>
+              </a:defRPr>
+            </a:pPr>
+            <a:r>
+              <a:t>気象予報 × 回帰モデル</a:t>
+            </a:r>
+          </a:p>
+        </p:txBody>
+      </p:sp>
+      <p:sp>
+        <p:nvSpPr>
+          <p:cNvPr id="9" name="Rounded Rectangle 8"/>
+          <p:cNvSpPr/>
+          <p:nvPr/>
+        </p:nvSpPr>
+        <p:spPr>
+          <a:xfrm>
+            <a:off x="4889377" y="1841500"/>
+            <a:ext cx="2857428" cy="838200"/>
+          </a:xfrm>
+          <a:prstGeom prst="roundRect">
+            <a:avLst/>
+          </a:prstGeom>
+          <a:solidFill>
+            <a:srgbClr val="EDF5FB"/>
+          </a:solidFill>
+          <a:ln>
+            <a:solidFill>
+              <a:srgbClr val="7BA4C7"/>
+            </a:solidFill>
+          </a:ln>
+        </p:spPr>
+        <p:style>
+          <a:lnRef idx="1">
+            <a:schemeClr val="accent1"/>
+          </a:lnRef>
+          <a:fillRef idx="3">
+            <a:schemeClr val="accent1"/>
+          </a:fillRef>
+          <a:effectRef idx="2">
+            <a:schemeClr val="accent1"/>
+          </a:effectRef>
+          <a:fontRef idx="minor">
+            <a:schemeClr val="lt1"/>
+          </a:fontRef>
+        </p:style>
+        <p:txBody>
+          <a:bodyPr rtlCol="0" anchor="ctr" wrap="square"/>
+          <a:lstStyle/>
+          <a:p>
+            <a:pPr algn="ctr">
+              <a:defRPr sz="1300" b="1">
+                <a:solidFill>
+                  <a:srgbClr val="0B3968"/>
+                </a:solidFill>
+                <a:latin typeface="BIZ UDPGothic"/>
+              </a:defRPr>
+            </a:pPr>
+            <a:r>
+              <a:t>削減効果の可視化</a:t>
+            </a:r>
+          </a:p>
+          <a:p>
+            <a:pPr algn="ctr">
+              <a:defRPr sz="1000">
+                <a:solidFill>
+                  <a:srgbClr val="555555"/>
+                </a:solidFill>
+                <a:latin typeface="BIZ UDPGothic"/>
+              </a:defRPr>
+            </a:pPr>
+            <a:r>
+              <a:t>トレードオフ曲線・UI</a:t>
+            </a:r>
+          </a:p>
+        </p:txBody>
+      </p:sp>
+      <p:sp>
+        <p:nvSpPr>
+          <p:cNvPr id="10" name="Rounded Rectangle 9"/>
+          <p:cNvSpPr/>
+          <p:nvPr/>
+        </p:nvSpPr>
+        <p:spPr>
+          <a:xfrm>
+            <a:off x="8572285" y="1841500"/>
+            <a:ext cx="2857428" cy="838200"/>
+          </a:xfrm>
+          <a:prstGeom prst="roundRect">
+            <a:avLst/>
+          </a:prstGeom>
+          <a:solidFill>
+            <a:srgbClr val="EDF5FB"/>
+          </a:solidFill>
+          <a:ln>
+            <a:solidFill>
+              <a:srgbClr val="7BA4C7"/>
+            </a:solidFill>
+          </a:ln>
+        </p:spPr>
+        <p:style>
+          <a:lnRef idx="1">
+            <a:schemeClr val="accent1"/>
+          </a:lnRef>
+          <a:fillRef idx="3">
+            <a:schemeClr val="accent1"/>
+          </a:fillRef>
+          <a:effectRef idx="2">
+            <a:schemeClr val="accent1"/>
+          </a:effectRef>
+          <a:fontRef idx="minor">
+            <a:schemeClr val="lt1"/>
+          </a:fontRef>
+        </p:style>
+        <p:txBody>
+          <a:bodyPr rtlCol="0" anchor="ctr" wrap="square"/>
+          <a:lstStyle/>
+          <a:p>
+            <a:pPr algn="ctr">
+              <a:defRPr sz="1300" b="1">
+                <a:solidFill>
+                  <a:srgbClr val="0B3968"/>
+                </a:solidFill>
+                <a:latin typeface="BIZ UDPGothic"/>
+              </a:defRPr>
+            </a:pPr>
+            <a:r>
+              <a:t>BM 意思決定</a:t>
+            </a:r>
+          </a:p>
+          <a:p>
+            <a:pPr algn="ctr">
+              <a:defRPr sz="1000">
+                <a:solidFill>
+                  <a:srgbClr val="555555"/>
+                </a:solidFill>
+                <a:latin typeface="BIZ UDPGothic"/>
+              </a:defRPr>
+            </a:pPr>
+            <a:r>
+              <a:t>安心・納得の起動判断</a:t>
+            </a:r>
+          </a:p>
+        </p:txBody>
+      </p:sp>
+      <p:sp>
+        <p:nvSpPr>
+          <p:cNvPr id="11" name="TextBox 10"/>
+          <p:cNvSpPr txBox="1"/>
+          <p:nvPr/>
+        </p:nvSpPr>
+        <p:spPr>
+          <a:xfrm>
+            <a:off x="571485" y="3175000"/>
+            <a:ext cx="7619809" cy="2794000"/>
+          </a:xfrm>
+          <a:prstGeom prst="rect">
+            <a:avLst/>
+          </a:prstGeom>
+          <a:noFill/>
+        </p:spPr>
+        <p:txBody>
+          <a:bodyPr wrap="square">
+            <a:spAutoFit/>
+          </a:bodyPr>
+          <a:lstStyle/>
+          <a:p>
+            <a:pPr>
+              <a:spcAft>
                 <a:spcPts val="400"/>
               </a:spcAft>
-              <a:defRPr sz="1600" b="1">
+              <a:defRPr sz="1500" b="1">
                 <a:solidFill>
                   <a:srgbClr val="0B3968"/>
                 </a:solidFill>
@@ -5021,7 +5296,7 @@
               </a:defRPr>
             </a:pPr>
             <a:r>
-              <a:t>■ 背景</a:t>
+              <a:t>■ 背景（なぜ今、熱源起動の最適化なのか）</a:t>
             </a:r>
           </a:p>
           <a:p>
@@ -5029,7 +5304,7 @@
               <a:spcAft>
                 <a:spcPts val="300"/>
               </a:spcAft>
-              <a:defRPr sz="1200">
+              <a:defRPr sz="1150">
                 <a:solidFill>
                   <a:srgbClr val="222222"/>
                 </a:solidFill>
@@ -5037,7 +5312,7 @@
               </a:defRPr>
             </a:pPr>
             <a:r>
-              <a:t>  ・近年、気候変動への対応や脱炭素に向け、ESG※1投資が世界的に拡大している</a:t>
+              <a:t>  ・【社会的要請】気候変動対応や脱炭素化に向け、ESG※1投資が世界的に拡大</a:t>
             </a:r>
           </a:p>
           <a:p>
@@ -5045,7 +5320,7 @@
               <a:spcAft>
                 <a:spcPts val="300"/>
               </a:spcAft>
-              <a:defRPr sz="1200">
+              <a:defRPr sz="1150">
                 <a:solidFill>
                   <a:srgbClr val="222222"/>
                 </a:solidFill>
@@ -5053,7 +5328,7 @@
               </a:defRPr>
             </a:pPr>
             <a:r>
-              <a:t>  ・快適性とエネルギーに関してシミュレーション技術で脱炭素化と企業価値向上に貢献する</a:t>
+              <a:t>  ・快適性とエネルギーに関してシミュレーション技術で脱炭素化と企業価値向上へ貢献</a:t>
             </a:r>
           </a:p>
           <a:p>
@@ -5061,7 +5336,7 @@
               <a:spcAft>
                 <a:spcPts val="300"/>
               </a:spcAft>
-              <a:defRPr sz="1200">
+              <a:defRPr sz="1150">
                 <a:solidFill>
                   <a:srgbClr val="222222"/>
                 </a:solidFill>
@@ -5069,88 +5344,21 @@
               </a:defRPr>
             </a:pPr>
             <a:r>
-              <a:t>  ・オフィスビルの熱源起動最適化に着目（※現場では未達を恐れ早朝一律の過剰予冷が発生）</a:t>
-            </a:r>
-          </a:p>
-          <a:p>
-            <a:pPr>
-              <a:spcBef>
-                <a:spcPts val="1200"/>
-              </a:spcBef>
-              <a:spcAft>
-                <a:spcPts val="400"/>
-              </a:spcAft>
-              <a:defRPr sz="1600" b="1">
-                <a:solidFill>
-                  <a:srgbClr val="0B3968"/>
-                </a:solidFill>
-                <a:latin typeface="BIZ UDPGothic"/>
-              </a:defRPr>
-            </a:pPr>
-            <a:r>
-              <a:t>■ 目的</a:t>
-            </a:r>
-          </a:p>
-          <a:p>
-            <a:pPr>
-              <a:spcAft>
-                <a:spcPts val="300"/>
-              </a:spcAft>
-              <a:defRPr sz="1200">
-                <a:solidFill>
-                  <a:srgbClr val="222222"/>
-                </a:solidFill>
-                <a:latin typeface="BIZ UDPGothic"/>
-              </a:defRPr>
-            </a:pPr>
-            <a:r>
-              <a:t>  ・空調熱源起動時刻をデータに基づいて最適化し、早朝予冷の無駄削減を目指す</a:t>
-            </a:r>
-          </a:p>
-          <a:p>
-            <a:pPr>
-              <a:spcAft>
-                <a:spcPts val="300"/>
-              </a:spcAft>
-              <a:defRPr sz="1200">
-                <a:solidFill>
-                  <a:srgbClr val="222222"/>
-                </a:solidFill>
-                <a:latin typeface="BIZ UDPGothic"/>
-              </a:defRPr>
-            </a:pPr>
-            <a:r>
-              <a:t>  ・それらの情報をわかりやすく可視化することで、ビルメンテナンス(BM)が根拠を持って</a:t>
-            </a:r>
-          </a:p>
-          <a:p>
-            <a:pPr>
-              <a:spcAft>
-                <a:spcPts val="300"/>
-              </a:spcAft>
-              <a:defRPr sz="1200">
-                <a:solidFill>
-                  <a:srgbClr val="222222"/>
-                </a:solidFill>
-                <a:latin typeface="BIZ UDPGothic"/>
-              </a:defRPr>
-            </a:pPr>
-            <a:r>
-              <a:t>     安全に起動時刻を判断できる意思決定支援システムを構築する</a:t>
-            </a:r>
-          </a:p>
-        </p:txBody>
-      </p:sp>
-      <p:sp>
-        <p:nvSpPr>
-          <p:cNvPr id="8" name="Rounded Rectangle 7"/>
+              <a:t>  ・【現場の実態】始業時の室温未達を恐れ、早朝一律の過剰予冷が発生し電力が浪費されている</a:t>
+            </a:r>
+          </a:p>
+        </p:txBody>
+      </p:sp>
+      <p:sp>
+        <p:nvSpPr>
+          <p:cNvPr id="12" name="Rounded Rectangle 11"/>
           <p:cNvSpPr/>
           <p:nvPr/>
         </p:nvSpPr>
         <p:spPr>
           <a:xfrm>
-            <a:off x="8508787" y="1143000"/>
-            <a:ext cx="3174920" cy="1079500"/>
+            <a:off x="8508787" y="3365500"/>
+            <a:ext cx="3174920" cy="1206500"/>
           </a:xfrm>
           <a:prstGeom prst="roundRect">
             <a:avLst/>
@@ -5231,210 +5439,6 @@
             </a:pPr>
             <a:r>
               <a:t>G(ガバナンス)：法令遵守・管理規則など</a:t>
-            </a:r>
-          </a:p>
-        </p:txBody>
-      </p:sp>
-      <p:sp>
-        <p:nvSpPr>
-          <p:cNvPr id="9" name="Rounded Rectangle 8"/>
-          <p:cNvSpPr/>
-          <p:nvPr/>
-        </p:nvSpPr>
-        <p:spPr>
-          <a:xfrm>
-            <a:off x="1206469" y="4762500"/>
-            <a:ext cx="2857428" cy="889000"/>
-          </a:xfrm>
-          <a:prstGeom prst="roundRect">
-            <a:avLst/>
-          </a:prstGeom>
-          <a:solidFill>
-            <a:srgbClr val="EDF5FB"/>
-          </a:solidFill>
-          <a:ln>
-            <a:solidFill>
-              <a:srgbClr val="7BA4C7"/>
-            </a:solidFill>
-          </a:ln>
-        </p:spPr>
-        <p:style>
-          <a:lnRef idx="1">
-            <a:schemeClr val="accent1"/>
-          </a:lnRef>
-          <a:fillRef idx="3">
-            <a:schemeClr val="accent1"/>
-          </a:fillRef>
-          <a:effectRef idx="2">
-            <a:schemeClr val="accent1"/>
-          </a:effectRef>
-          <a:fontRef idx="minor">
-            <a:schemeClr val="lt1"/>
-          </a:fontRef>
-        </p:style>
-        <p:txBody>
-          <a:bodyPr rtlCol="0" anchor="ctr" wrap="square"/>
-          <a:lstStyle/>
-          <a:p>
-            <a:pPr algn="ctr">
-              <a:defRPr sz="1300" b="1">
-                <a:solidFill>
-                  <a:srgbClr val="0B3968"/>
-                </a:solidFill>
-                <a:latin typeface="BIZ UDPGothic"/>
-              </a:defRPr>
-            </a:pPr>
-            <a:r>
-              <a:t>必要な予冷時間の予測</a:t>
-            </a:r>
-          </a:p>
-          <a:p>
-            <a:pPr algn="ctr">
-              <a:defRPr sz="1000">
-                <a:solidFill>
-                  <a:srgbClr val="555555"/>
-                </a:solidFill>
-                <a:latin typeface="BIZ UDPGothic"/>
-              </a:defRPr>
-            </a:pPr>
-            <a:r>
-              <a:t>気象予報 × 回帰モデル</a:t>
-            </a:r>
-          </a:p>
-        </p:txBody>
-      </p:sp>
-      <p:sp>
-        <p:nvSpPr>
-          <p:cNvPr id="10" name="Rounded Rectangle 9"/>
-          <p:cNvSpPr/>
-          <p:nvPr/>
-        </p:nvSpPr>
-        <p:spPr>
-          <a:xfrm>
-            <a:off x="4889377" y="4762500"/>
-            <a:ext cx="2857428" cy="889000"/>
-          </a:xfrm>
-          <a:prstGeom prst="roundRect">
-            <a:avLst/>
-          </a:prstGeom>
-          <a:solidFill>
-            <a:srgbClr val="EDF5FB"/>
-          </a:solidFill>
-          <a:ln>
-            <a:solidFill>
-              <a:srgbClr val="7BA4C7"/>
-            </a:solidFill>
-          </a:ln>
-        </p:spPr>
-        <p:style>
-          <a:lnRef idx="1">
-            <a:schemeClr val="accent1"/>
-          </a:lnRef>
-          <a:fillRef idx="3">
-            <a:schemeClr val="accent1"/>
-          </a:fillRef>
-          <a:effectRef idx="2">
-            <a:schemeClr val="accent1"/>
-          </a:effectRef>
-          <a:fontRef idx="minor">
-            <a:schemeClr val="lt1"/>
-          </a:fontRef>
-        </p:style>
-        <p:txBody>
-          <a:bodyPr rtlCol="0" anchor="ctr" wrap="square"/>
-          <a:lstStyle/>
-          <a:p>
-            <a:pPr algn="ctr">
-              <a:defRPr sz="1300" b="1">
-                <a:solidFill>
-                  <a:srgbClr val="0B3968"/>
-                </a:solidFill>
-                <a:latin typeface="BIZ UDPGothic"/>
-              </a:defRPr>
-            </a:pPr>
-            <a:r>
-              <a:t>削減効果の可視化</a:t>
-            </a:r>
-          </a:p>
-          <a:p>
-            <a:pPr algn="ctr">
-              <a:defRPr sz="1000">
-                <a:solidFill>
-                  <a:srgbClr val="555555"/>
-                </a:solidFill>
-                <a:latin typeface="BIZ UDPGothic"/>
-              </a:defRPr>
-            </a:pPr>
-            <a:r>
-              <a:t>トレードオフ曲線・UI</a:t>
-            </a:r>
-          </a:p>
-        </p:txBody>
-      </p:sp>
-      <p:sp>
-        <p:nvSpPr>
-          <p:cNvPr id="11" name="Rounded Rectangle 10"/>
-          <p:cNvSpPr/>
-          <p:nvPr/>
-        </p:nvSpPr>
-        <p:spPr>
-          <a:xfrm>
-            <a:off x="8572285" y="4762500"/>
-            <a:ext cx="2857428" cy="889000"/>
-          </a:xfrm>
-          <a:prstGeom prst="roundRect">
-            <a:avLst/>
-          </a:prstGeom>
-          <a:solidFill>
-            <a:srgbClr val="EDF5FB"/>
-          </a:solidFill>
-          <a:ln>
-            <a:solidFill>
-              <a:srgbClr val="7BA4C7"/>
-            </a:solidFill>
-          </a:ln>
-        </p:spPr>
-        <p:style>
-          <a:lnRef idx="1">
-            <a:schemeClr val="accent1"/>
-          </a:lnRef>
-          <a:fillRef idx="3">
-            <a:schemeClr val="accent1"/>
-          </a:fillRef>
-          <a:effectRef idx="2">
-            <a:schemeClr val="accent1"/>
-          </a:effectRef>
-          <a:fontRef idx="minor">
-            <a:schemeClr val="lt1"/>
-          </a:fontRef>
-        </p:style>
-        <p:txBody>
-          <a:bodyPr rtlCol="0" anchor="ctr" wrap="square"/>
-          <a:lstStyle/>
-          <a:p>
-            <a:pPr algn="ctr">
-              <a:defRPr sz="1300" b="1">
-                <a:solidFill>
-                  <a:srgbClr val="0B3968"/>
-                </a:solidFill>
-                <a:latin typeface="BIZ UDPGothic"/>
-              </a:defRPr>
-            </a:pPr>
-            <a:r>
-              <a:t>BM 意思決定</a:t>
-            </a:r>
-          </a:p>
-          <a:p>
-            <a:pPr algn="ctr">
-              <a:defRPr sz="1000">
-                <a:solidFill>
-                  <a:srgbClr val="555555"/>
-                </a:solidFill>
-                <a:latin typeface="BIZ UDPGothic"/>
-              </a:defRPr>
-            </a:pPr>
-            <a:r>
-              <a:t>安心・納得の起動判断</a:t>
             </a:r>
           </a:p>
         </p:txBody>

</xml_diff>

<commit_message>
content(hvac): eliminate '実データ' terminology in favor of telemetry data
</commit_message>
<xml_diff>
--- a/public/slides/hvac-precooling-slides.pptx
+++ b/public/slides/hvac-precooling-slides.pptx
@@ -580,7 +580,7 @@
           <a:lstStyle/>
           <a:p>
             <a:r>
-              <a:t>まず初めに、自己紹介をさせていただきます。私は北海道大学大学院情報科学専攻で、遺伝子ネットワークモデルの制御や投薬順序の最適化に関する研究を行っています。趣味は鉄道旅行です。今回のインターンシップには、「大学では扱えない実機・現場の実データに触れたい」「お客様目線でのシステム開発を学びたい」「関西の活気ある雰囲気を感じたい」という3つの理由から参加いたしました。</a:t>
+              <a:t>まず初めに、自己紹介をさせていただきます。私は北海道大学大学院情報科学専攻で、遺伝子ネットワークモデルの制御や投薬順序の最適化に関する研究を行っています。趣味は鉄道旅行です。今回のインターンシップには、「大学では扱えない実機設備や現場データに触れたい」「お客様目線でのシステム開発を学びたい」「関西の活気ある雰囲気を感じたい」という3つの理由から参加いたしました。</a:t>
             </a:r>
           </a:p>
         </p:txBody>
@@ -860,7 +860,7 @@
           <a:lstStyle/>
           <a:p>
             <a:r>
-              <a:t>開発した最適起動モデルを実データに適用した、バックテスト検証結果です。過去データの実測気温推移からモデルで予冷時間を推計し、始業8:00から逆算して、確実に間に合う範囲で最も遅い起動時刻を決定し直しました。その結果、全日で8:00始業前の設定温度到達を達成できました。効果として、まず運転時間は平均で約104分短縮され、最大で1時間40分ほど起動を遅らせることができました。その結果、始業前の消費電力量は平均で約36%削減できることを確認いたしました。</a:t>
+              <a:t>開発した最適起動モデルを過去の運用実績データに適用した、バックテスト検証結果です。過去データの実測気温推移からモデルで予冷時間を推計し、始業8:00から逆算して、確実に間に合う範囲で最も遅い起動時刻を決定し直しました。その結果、全日で8:00始業前の設定温度到達を達成できました。効果として、まず運転時間は平均で約104分短縮され、最大で1時間40分ほど起動を遅らせることができました。その結果、始業前の消費電力量は平均で約36%削減できることを確認いたしました。</a:t>
             </a:r>
           </a:p>
         </p:txBody>
@@ -1070,7 +1070,7 @@
           <a:lstStyle/>
           <a:p>
             <a:r>
-              <a:t>最後に、2週間の実習を通した所感です。初日の自己紹介で挙げた「3つの参加理由」に対し、期待を大きく超える充実した学びを得ることができました。まず開発面では、単に予測モデルを作るだけでなく、現場のBM担当者がどうすれば安心して起動を遅らせられるかという「お客様目線」でのUI・安全マージン設計の難しさと重要性を深く学びました。また、大学では扱えない実機データに触れる中で、シミュレーション技術が脱炭素や社会貢献に直結しているという強い手応えを得ることができました。そしてインターンシップ全体を通じ、デスクワークにとどまらず実験住宅やセキュリティ現場の見学など幅広い体験をさせていただき、当社の高い技術力と現場主義の社風を肌で体感いたしました。親身にご指導いただいたメンターの皆様、関係者の皆様に心より感謝申し上げます。2週間、本当にありがとうございました。</a:t>
+              <a:t>最後に、2週間の実習を通した所感です。初日の自己紹介で挙げた「3つの参加理由」に対し、期待を大きく超える充実した学びを得ることができました。まず開発面では、単に予測モデルを作るだけでなく、現場のBM担当者がどうすれば安心して起動を遅らせられるかという「お客様目線」でのUI・安全マージン設計の難しさと重要性を深く学びました。また、大学では扱えない実機設備や現場データに触れる中で、シミュレーション技術が脱炭素や社会貢献に直結しているという強い手応えを得ることができました。そしてインターンシップ全体を通じ、デスクワークにとどまらず実験住宅やセキュリティ現場の見学など幅広い体験をさせていただき、当社の高い技術力と現場主義の社風を肌で体感いたしました。親身にご指導いただいたメンターの皆様、関係者の皆様に心より感謝申し上げます。2週間、本当にありがとうございました。</a:t>
             </a:r>
           </a:p>
         </p:txBody>
@@ -4591,7 +4591,7 @@
               </a:defRPr>
             </a:pPr>
             <a:r>
-              <a:t>   ① 大学では扱えない実データに触れる</a:t>
+              <a:t>   ① 大学では扱えない実機設備・データに触れる</a:t>
             </a:r>
           </a:p>
           <a:p>
@@ -6703,7 +6703,7 @@
               </a:defRPr>
             </a:pPr>
             <a:r>
-              <a:t>■ 実データでの検証</a:t>
+              <a:t>■ 運用実績データでの検証</a:t>
             </a:r>
           </a:p>
           <a:p>
@@ -6716,7 +6716,7 @@
               </a:defRPr>
             </a:pPr>
             <a:r>
-              <a:t>  ・作成した予測モデルを用い、実際の過去データの気温推移から必要な予冷時間を推測、起動時間を決定した</a:t>
+              <a:t>  ・作成した予測モデルを用い、過去の気温推移から必要な予冷時間を予測、起動時間を決定した</a:t>
             </a:r>
           </a:p>
           <a:p>

</xml_diff>